<commit_message>
docs: larger fonts in SIH deck
Co-Authored-By: Claude Opus 5.5 <noreply@anthropic.com>
</commit_message>
<xml_diff>
--- a/PathSense_SIH_Final_Presentation.pptx
+++ b/PathSense_SIH_Final_Presentation.pptx
@@ -4281,7 +4281,7 @@
           <a:p>
             <a:pPr algn="l"/>
             <a:r>
-              <a:rPr sz="1700" b="1" i="0" u="none">
+              <a:rPr sz="2000" b="1" i="0" u="none">
                 <a:solidFill>
                   <a:srgbClr val="1B2A41"/>
                 </a:solidFill>
@@ -4316,7 +4316,7 @@
           <a:p>
             <a:pPr algn="l"/>
             <a:r>
-              <a:rPr sz="1050" b="0" i="1" u="none">
+              <a:rPr sz="1250" b="0" i="1" u="none">
                 <a:solidFill>
                   <a:srgbClr val="1F497D"/>
                 </a:solidFill>
@@ -4469,7 +4469,7 @@
           <a:p>
             <a:pPr algn="l"/>
             <a:r>
-              <a:rPr sz="1300" b="1" i="0" u="none">
+              <a:rPr sz="1550" b="1" i="0" u="none">
                 <a:solidFill>
                   <a:srgbClr val="1B2A41"/>
                 </a:solidFill>
@@ -4508,7 +4508,7 @@
               </a:lnSpc>
             </a:pPr>
             <a:r>
-              <a:rPr sz="1400" b="0" i="0" u="none">
+              <a:rPr sz="1650" b="0" i="0" u="none">
                 <a:solidFill>
                   <a:srgbClr val="243044"/>
                 </a:solidFill>
@@ -4543,7 +4543,7 @@
           <a:p>
             <a:pPr algn="l"/>
             <a:r>
-              <a:rPr sz="1150" b="0" i="0" u="sng">
+              <a:rPr sz="1350" b="0" i="0" u="sng">
                 <a:solidFill>
                   <a:srgbClr val="1155CC"/>
                 </a:solidFill>
@@ -4697,7 +4697,7 @@
           <a:p>
             <a:pPr algn="l"/>
             <a:r>
-              <a:rPr sz="1300" b="1" i="0" u="none">
+              <a:rPr sz="1550" b="1" i="0" u="none">
                 <a:solidFill>
                   <a:srgbClr val="1B2A41"/>
                 </a:solidFill>
@@ -4736,7 +4736,7 @@
               </a:lnSpc>
             </a:pPr>
             <a:r>
-              <a:rPr sz="1400" b="0" i="0" u="none">
+              <a:rPr sz="1650" b="0" i="0" u="none">
                 <a:solidFill>
                   <a:srgbClr val="243044"/>
                 </a:solidFill>
@@ -4771,7 +4771,7 @@
           <a:p>
             <a:pPr algn="l"/>
             <a:r>
-              <a:rPr sz="1150" b="0" i="0" u="sng">
+              <a:rPr sz="1350" b="0" i="0" u="sng">
                 <a:solidFill>
                   <a:srgbClr val="1155CC"/>
                 </a:solidFill>
@@ -4925,7 +4925,7 @@
           <a:p>
             <a:pPr algn="l"/>
             <a:r>
-              <a:rPr sz="1300" b="1" i="0" u="none">
+              <a:rPr sz="1550" b="1" i="0" u="none">
                 <a:solidFill>
                   <a:srgbClr val="1B2A41"/>
                 </a:solidFill>
@@ -4964,7 +4964,7 @@
               </a:lnSpc>
             </a:pPr>
             <a:r>
-              <a:rPr sz="1400" b="0" i="0" u="none">
+              <a:rPr sz="1650" b="0" i="0" u="none">
                 <a:solidFill>
                   <a:srgbClr val="243044"/>
                 </a:solidFill>
@@ -4999,7 +4999,7 @@
           <a:p>
             <a:pPr algn="l"/>
             <a:r>
-              <a:rPr sz="1150" b="0" i="0" u="sng">
+              <a:rPr sz="1350" b="0" i="0" u="sng">
                 <a:solidFill>
                   <a:srgbClr val="1155CC"/>
                 </a:solidFill>
@@ -5153,7 +5153,7 @@
           <a:p>
             <a:pPr algn="l"/>
             <a:r>
-              <a:rPr sz="1300" b="1" i="0" u="none">
+              <a:rPr sz="1550" b="1" i="0" u="none">
                 <a:solidFill>
                   <a:srgbClr val="1B2A41"/>
                 </a:solidFill>
@@ -5192,7 +5192,7 @@
               </a:lnSpc>
             </a:pPr>
             <a:r>
-              <a:rPr sz="1400" b="0" i="0" u="none">
+              <a:rPr sz="1650" b="0" i="0" u="none">
                 <a:solidFill>
                   <a:srgbClr val="243044"/>
                 </a:solidFill>
@@ -5227,7 +5227,7 @@
           <a:p>
             <a:pPr algn="l"/>
             <a:r>
-              <a:rPr sz="1150" b="0" i="0" u="sng">
+              <a:rPr sz="1350" b="0" i="0" u="sng">
                 <a:solidFill>
                   <a:srgbClr val="1155CC"/>
                 </a:solidFill>
@@ -5381,7 +5381,7 @@
           <a:p>
             <a:pPr algn="l"/>
             <a:r>
-              <a:rPr sz="1300" b="1" i="0" u="none">
+              <a:rPr sz="1550" b="1" i="0" u="none">
                 <a:solidFill>
                   <a:srgbClr val="1B2A41"/>
                 </a:solidFill>
@@ -5420,7 +5420,7 @@
               </a:lnSpc>
             </a:pPr>
             <a:r>
-              <a:rPr sz="1400" b="0" i="0" u="none">
+              <a:rPr sz="1650" b="0" i="0" u="none">
                 <a:solidFill>
                   <a:srgbClr val="243044"/>
                 </a:solidFill>
@@ -5455,7 +5455,7 @@
           <a:p>
             <a:pPr algn="l"/>
             <a:r>
-              <a:rPr sz="1150" b="0" i="0" u="sng">
+              <a:rPr sz="1350" b="0" i="0" u="sng">
                 <a:solidFill>
                   <a:srgbClr val="1155CC"/>
                 </a:solidFill>
@@ -5609,7 +5609,7 @@
           <a:p>
             <a:pPr algn="l"/>
             <a:r>
-              <a:rPr sz="1300" b="1" i="0" u="none">
+              <a:rPr sz="1550" b="1" i="0" u="none">
                 <a:solidFill>
                   <a:srgbClr val="1B2A41"/>
                 </a:solidFill>
@@ -5648,7 +5648,7 @@
               </a:lnSpc>
             </a:pPr>
             <a:r>
-              <a:rPr sz="1400" b="0" i="0" u="none">
+              <a:rPr sz="1650" b="0" i="0" u="none">
                 <a:solidFill>
                   <a:srgbClr val="243044"/>
                 </a:solidFill>
@@ -5683,7 +5683,7 @@
           <a:p>
             <a:pPr algn="l"/>
             <a:r>
-              <a:rPr sz="1150" b="0" i="0" u="sng">
+              <a:rPr sz="1350" b="0" i="0" u="sng">
                 <a:solidFill>
                   <a:srgbClr val="1155CC"/>
                 </a:solidFill>
@@ -5837,7 +5837,7 @@
           <a:p>
             <a:pPr algn="l"/>
             <a:r>
-              <a:rPr sz="1300" b="1" i="0" u="none">
+              <a:rPr sz="1550" b="1" i="0" u="none">
                 <a:solidFill>
                   <a:srgbClr val="1B2A41"/>
                 </a:solidFill>
@@ -5876,7 +5876,7 @@
               </a:lnSpc>
             </a:pPr>
             <a:r>
-              <a:rPr sz="1400" b="0" i="0" u="none">
+              <a:rPr sz="1650" b="0" i="0" u="none">
                 <a:solidFill>
                   <a:srgbClr val="243044"/>
                 </a:solidFill>
@@ -5911,7 +5911,7 @@
           <a:p>
             <a:pPr algn="l"/>
             <a:r>
-              <a:rPr sz="1150" b="0" i="0" u="sng">
+              <a:rPr sz="1350" b="0" i="0" u="sng">
                 <a:solidFill>
                   <a:srgbClr val="1155CC"/>
                 </a:solidFill>
@@ -6065,7 +6065,7 @@
           <a:p>
             <a:pPr algn="l"/>
             <a:r>
-              <a:rPr sz="1300" b="1" i="0" u="none">
+              <a:rPr sz="1550" b="1" i="0" u="none">
                 <a:solidFill>
                   <a:srgbClr val="1B2A41"/>
                 </a:solidFill>
@@ -6104,7 +6104,7 @@
               </a:lnSpc>
             </a:pPr>
             <a:r>
-              <a:rPr sz="1400" b="0" i="0" u="none">
+              <a:rPr sz="1650" b="0" i="0" u="none">
                 <a:solidFill>
                   <a:srgbClr val="243044"/>
                 </a:solidFill>
@@ -6139,7 +6139,7 @@
           <a:p>
             <a:pPr algn="l"/>
             <a:r>
-              <a:rPr sz="1150" b="0" i="0" u="sng">
+              <a:rPr sz="1350" b="0" i="0" u="sng">
                 <a:solidFill>
                   <a:srgbClr val="1155CC"/>
                 </a:solidFill>
@@ -6710,7 +6710,7 @@
           <a:p>
             <a:pPr algn="ctr"/>
             <a:r>
-              <a:rPr sz="1600" b="1" i="0" u="none">
+              <a:rPr sz="1900" b="1" i="0" u="none">
                 <a:solidFill>
                   <a:srgbClr val="0B7468"/>
                 </a:solidFill>
@@ -6815,7 +6815,7 @@
           <a:p>
             <a:pPr algn="l"/>
             <a:r>
-              <a:rPr sz="1700" b="1" i="0" u="none">
+              <a:rPr sz="2000" b="1" i="0" u="none">
                 <a:solidFill>
                   <a:srgbClr val="1B2A41"/>
                 </a:solidFill>
@@ -6850,7 +6850,7 @@
           <a:p>
             <a:pPr algn="l"/>
             <a:r>
-              <a:rPr sz="1050" b="0" i="1" u="none">
+              <a:rPr sz="1250" b="0" i="1" u="none">
                 <a:solidFill>
                   <a:srgbClr val="1F497D"/>
                 </a:solidFill>
@@ -6940,7 +6940,7 @@
               </a:spcAft>
             </a:pPr>
             <a:r>
-              <a:rPr sz="1200" b="1" i="0" u="none">
+              <a:rPr sz="1400" b="1" i="0" u="none">
                 <a:solidFill>
                   <a:srgbClr val="0B7468"/>
                 </a:solidFill>
@@ -6949,7 +6949,7 @@
               <a:t>PathSense</a:t>
             </a:r>
             <a:r>
-              <a:rPr sz="1200" b="0" i="0" u="none">
+              <a:rPr sz="1400" b="0" i="0" u="none">
                 <a:solidFill>
                   <a:srgbClr val="243044"/>
                 </a:solidFill>
@@ -6968,7 +6968,7 @@
               </a:spcAft>
             </a:pPr>
             <a:r>
-              <a:rPr sz="1200" b="0" i="0" u="none">
+              <a:rPr sz="1400" b="0" i="0" u="none">
                 <a:solidFill>
                   <a:srgbClr val="243044"/>
                 </a:solidFill>
@@ -6977,7 +6977,7 @@
               <a:t>It reasons about </a:t>
             </a:r>
             <a:r>
-              <a:rPr sz="1200" b="1" i="0" u="none">
+              <a:rPr sz="1400" b="1" i="0" u="none">
                 <a:solidFill>
                   <a:srgbClr val="243044"/>
                 </a:solidFill>
@@ -6986,7 +6986,7 @@
               <a:t>mixed traffic</a:t>
             </a:r>
             <a:r>
-              <a:rPr sz="1200" b="0" i="0" u="none">
+              <a:rPr sz="1400" b="0" i="0" u="none">
                 <a:solidFill>
                   <a:srgbClr val="243044"/>
                 </a:solidFill>
@@ -6995,7 +6995,7 @@
               <a:t> — pedestrians, motorcycles, auto-rickshaws, cars, buses, trucks and animals — on roads with </a:t>
             </a:r>
             <a:r>
-              <a:rPr sz="1200" b="1" i="0" u="none">
+              <a:rPr sz="1400" b="1" i="0" u="none">
                 <a:solidFill>
                   <a:srgbClr val="243044"/>
                 </a:solidFill>
@@ -7004,7 +7004,7 @@
               <a:t>missing or unclear lane markings</a:t>
             </a:r>
             <a:r>
-              <a:rPr sz="1200" b="0" i="0" u="none">
+              <a:rPr sz="1400" b="0" i="0" u="none">
                 <a:solidFill>
                   <a:srgbClr val="243044"/>
                 </a:solidFill>
@@ -7068,7 +7068,7 @@
           <a:p>
             <a:pPr algn="r"/>
             <a:r>
-              <a:rPr sz="800" b="0" i="1" u="none">
+              <a:rPr sz="950" b="0" i="1" u="none">
                 <a:solidFill>
                   <a:srgbClr val="5B6778"/>
                 </a:solidFill>
@@ -7173,7 +7173,7 @@
           <a:p>
             <a:pPr algn="l"/>
             <a:r>
-              <a:rPr sz="1700" b="1" i="0" u="none">
+              <a:rPr sz="2000" b="1" i="0" u="none">
                 <a:solidFill>
                   <a:srgbClr val="1B2A41"/>
                 </a:solidFill>
@@ -7208,7 +7208,7 @@
           <a:p>
             <a:pPr algn="l"/>
             <a:r>
-              <a:rPr sz="1050" b="0" i="1" u="none">
+              <a:rPr sz="1250" b="0" i="1" u="none">
                 <a:solidFill>
                   <a:srgbClr val="1F497D"/>
                 </a:solidFill>
@@ -7291,7 +7291,7 @@
           <a:p>
             <a:pPr algn="l"/>
             <a:r>
-              <a:rPr sz="1300" b="1" i="0" u="none">
+              <a:rPr sz="1550" b="1" i="0" u="none">
                 <a:solidFill>
                   <a:srgbClr val="0F9E8E"/>
                 </a:solidFill>
@@ -7350,7 +7350,7 @@
           <a:p>
             <a:pPr algn="l"/>
             <a:r>
-              <a:rPr sz="1150" b="1" i="0" u="none">
+              <a:rPr sz="1350" b="1" i="0" u="none">
                 <a:solidFill>
                   <a:srgbClr val="1B2A41"/>
                 </a:solidFill>
@@ -7385,7 +7385,7 @@
           <a:p>
             <a:pPr algn="l"/>
             <a:r>
-              <a:rPr sz="950" b="0" i="0" u="none">
+              <a:rPr sz="1100" b="0" i="0" u="none">
                 <a:solidFill>
                   <a:srgbClr val="5B6778"/>
                 </a:solidFill>
@@ -7468,7 +7468,7 @@
           <a:p>
             <a:pPr algn="l"/>
             <a:r>
-              <a:rPr sz="1300" b="1" i="0" u="none">
+              <a:rPr sz="1550" b="1" i="0" u="none">
                 <a:solidFill>
                   <a:srgbClr val="0F9E8E"/>
                 </a:solidFill>
@@ -7527,7 +7527,7 @@
           <a:p>
             <a:pPr algn="l"/>
             <a:r>
-              <a:rPr sz="1150" b="1" i="0" u="none">
+              <a:rPr sz="1350" b="1" i="0" u="none">
                 <a:solidFill>
                   <a:srgbClr val="1B2A41"/>
                 </a:solidFill>
@@ -7562,7 +7562,7 @@
           <a:p>
             <a:pPr algn="l"/>
             <a:r>
-              <a:rPr sz="950" b="0" i="0" u="none">
+              <a:rPr sz="1100" b="0" i="0" u="none">
                 <a:solidFill>
                   <a:srgbClr val="5B6778"/>
                 </a:solidFill>
@@ -7645,7 +7645,7 @@
           <a:p>
             <a:pPr algn="l"/>
             <a:r>
-              <a:rPr sz="1300" b="1" i="0" u="none">
+              <a:rPr sz="1550" b="1" i="0" u="none">
                 <a:solidFill>
                   <a:srgbClr val="0F9E8E"/>
                 </a:solidFill>
@@ -7704,7 +7704,7 @@
           <a:p>
             <a:pPr algn="l"/>
             <a:r>
-              <a:rPr sz="1150" b="1" i="0" u="none">
+              <a:rPr sz="1350" b="1" i="0" u="none">
                 <a:solidFill>
                   <a:srgbClr val="1B2A41"/>
                 </a:solidFill>
@@ -7739,7 +7739,7 @@
           <a:p>
             <a:pPr algn="l"/>
             <a:r>
-              <a:rPr sz="950" b="0" i="0" u="none">
+              <a:rPr sz="1100" b="0" i="0" u="none">
                 <a:solidFill>
                   <a:srgbClr val="5B6778"/>
                 </a:solidFill>
@@ -7822,7 +7822,7 @@
           <a:p>
             <a:pPr algn="l"/>
             <a:r>
-              <a:rPr sz="1300" b="1" i="0" u="none">
+              <a:rPr sz="1550" b="1" i="0" u="none">
                 <a:solidFill>
                   <a:srgbClr val="0F9E8E"/>
                 </a:solidFill>
@@ -7881,7 +7881,7 @@
           <a:p>
             <a:pPr algn="l"/>
             <a:r>
-              <a:rPr sz="1150" b="1" i="0" u="none">
+              <a:rPr sz="1350" b="1" i="0" u="none">
                 <a:solidFill>
                   <a:srgbClr val="1B2A41"/>
                 </a:solidFill>
@@ -7916,7 +7916,7 @@
           <a:p>
             <a:pPr algn="l"/>
             <a:r>
-              <a:rPr sz="950" b="0" i="0" u="none">
+              <a:rPr sz="1100" b="0" i="0" u="none">
                 <a:solidFill>
                   <a:srgbClr val="5B6778"/>
                 </a:solidFill>
@@ -7999,7 +7999,7 @@
           <a:p>
             <a:pPr algn="l"/>
             <a:r>
-              <a:rPr sz="1300" b="1" i="0" u="none">
+              <a:rPr sz="1550" b="1" i="0" u="none">
                 <a:solidFill>
                   <a:srgbClr val="0F9E8E"/>
                 </a:solidFill>
@@ -8058,7 +8058,7 @@
           <a:p>
             <a:pPr algn="l"/>
             <a:r>
-              <a:rPr sz="1150" b="1" i="0" u="none">
+              <a:rPr sz="1350" b="1" i="0" u="none">
                 <a:solidFill>
                   <a:srgbClr val="1B2A41"/>
                 </a:solidFill>
@@ -8093,7 +8093,7 @@
           <a:p>
             <a:pPr algn="l"/>
             <a:r>
-              <a:rPr sz="950" b="0" i="0" u="none">
+              <a:rPr sz="1100" b="0" i="0" u="none">
                 <a:solidFill>
                   <a:srgbClr val="5B6778"/>
                 </a:solidFill>
@@ -8176,7 +8176,7 @@
           <a:p>
             <a:pPr algn="l"/>
             <a:r>
-              <a:rPr sz="1300" b="1" i="0" u="none">
+              <a:rPr sz="1550" b="1" i="0" u="none">
                 <a:solidFill>
                   <a:srgbClr val="0F9E8E"/>
                 </a:solidFill>
@@ -8235,7 +8235,7 @@
           <a:p>
             <a:pPr algn="l"/>
             <a:r>
-              <a:rPr sz="1150" b="1" i="0" u="none">
+              <a:rPr sz="1350" b="1" i="0" u="none">
                 <a:solidFill>
                   <a:srgbClr val="1B2A41"/>
                 </a:solidFill>
@@ -8270,7 +8270,7 @@
           <a:p>
             <a:pPr algn="l"/>
             <a:r>
-              <a:rPr sz="950" b="0" i="0" u="none">
+              <a:rPr sz="1100" b="0" i="0" u="none">
                 <a:solidFill>
                   <a:srgbClr val="5B6778"/>
                 </a:solidFill>
@@ -8353,7 +8353,7 @@
           <a:p>
             <a:pPr algn="l"/>
             <a:r>
-              <a:rPr sz="1300" b="1" i="0" u="none">
+              <a:rPr sz="1550" b="1" i="0" u="none">
                 <a:solidFill>
                   <a:srgbClr val="0F9E8E"/>
                 </a:solidFill>
@@ -8412,7 +8412,7 @@
           <a:p>
             <a:pPr algn="l"/>
             <a:r>
-              <a:rPr sz="1150" b="1" i="0" u="none">
+              <a:rPr sz="1350" b="1" i="0" u="none">
                 <a:solidFill>
                   <a:srgbClr val="1B2A41"/>
                 </a:solidFill>
@@ -8447,7 +8447,7 @@
           <a:p>
             <a:pPr algn="l"/>
             <a:r>
-              <a:rPr sz="950" b="0" i="0" u="none">
+              <a:rPr sz="1100" b="0" i="0" u="none">
                 <a:solidFill>
                   <a:srgbClr val="5B6778"/>
                 </a:solidFill>
@@ -8530,7 +8530,7 @@
           <a:p>
             <a:pPr algn="l"/>
             <a:r>
-              <a:rPr sz="1300" b="1" i="0" u="none">
+              <a:rPr sz="1550" b="1" i="0" u="none">
                 <a:solidFill>
                   <a:srgbClr val="0F9E8E"/>
                 </a:solidFill>
@@ -8589,7 +8589,7 @@
           <a:p>
             <a:pPr algn="l"/>
             <a:r>
-              <a:rPr sz="1150" b="1" i="0" u="none">
+              <a:rPr sz="1350" b="1" i="0" u="none">
                 <a:solidFill>
                   <a:srgbClr val="1B2A41"/>
                 </a:solidFill>
@@ -8624,7 +8624,7 @@
           <a:p>
             <a:pPr algn="l"/>
             <a:r>
-              <a:rPr sz="950" b="0" i="0" u="none">
+              <a:rPr sz="1100" b="0" i="0" u="none">
                 <a:solidFill>
                   <a:srgbClr val="5B6778"/>
                 </a:solidFill>
@@ -8729,7 +8729,7 @@
           <a:p>
             <a:pPr algn="l"/>
             <a:r>
-              <a:rPr sz="1700" b="1" i="0" u="none">
+              <a:rPr sz="2000" b="1" i="0" u="none">
                 <a:solidFill>
                   <a:srgbClr val="1B2A41"/>
                 </a:solidFill>
@@ -8764,7 +8764,7 @@
           <a:p>
             <a:pPr algn="l"/>
             <a:r>
-              <a:rPr sz="1050" b="0" i="1" u="none">
+              <a:rPr sz="1250" b="0" i="1" u="none">
                 <a:solidFill>
                   <a:srgbClr val="1F497D"/>
                 </a:solidFill>
@@ -8893,7 +8893,7 @@
           <a:p>
             <a:pPr algn="ctr"/>
             <a:r>
-              <a:rPr sz="1500" b="1" i="0" u="none">
+              <a:rPr sz="1750" b="1" i="0" u="none">
                 <a:solidFill>
                   <a:srgbClr val="FFFFFF"/>
                 </a:solidFill>
@@ -8928,7 +8928,7 @@
           <a:p>
             <a:pPr algn="l"/>
             <a:r>
-              <a:rPr sz="1250" b="1" i="0" u="none">
+              <a:rPr sz="1500" b="1" i="0" u="none">
                 <a:solidFill>
                   <a:srgbClr val="1B2A41"/>
                 </a:solidFill>
@@ -8963,7 +8963,7 @@
           <a:p>
             <a:pPr algn="l"/>
             <a:r>
-              <a:rPr sz="1050" b="0" i="0" u="none">
+              <a:rPr sz="1250" b="0" i="0" u="none">
                 <a:solidFill>
                   <a:srgbClr val="5B6778"/>
                 </a:solidFill>
@@ -9092,7 +9092,7 @@
           <a:p>
             <a:pPr algn="ctr"/>
             <a:r>
-              <a:rPr sz="1500" b="1" i="0" u="none">
+              <a:rPr sz="1750" b="1" i="0" u="none">
                 <a:solidFill>
                   <a:srgbClr val="FFFFFF"/>
                 </a:solidFill>
@@ -9127,7 +9127,7 @@
           <a:p>
             <a:pPr algn="l"/>
             <a:r>
-              <a:rPr sz="1250" b="1" i="0" u="none">
+              <a:rPr sz="1500" b="1" i="0" u="none">
                 <a:solidFill>
                   <a:srgbClr val="1B2A41"/>
                 </a:solidFill>
@@ -9162,7 +9162,7 @@
           <a:p>
             <a:pPr algn="l"/>
             <a:r>
-              <a:rPr sz="1050" b="0" i="0" u="none">
+              <a:rPr sz="1250" b="0" i="0" u="none">
                 <a:solidFill>
                   <a:srgbClr val="5B6778"/>
                 </a:solidFill>
@@ -9291,7 +9291,7 @@
           <a:p>
             <a:pPr algn="ctr"/>
             <a:r>
-              <a:rPr sz="1500" b="1" i="0" u="none">
+              <a:rPr sz="1750" b="1" i="0" u="none">
                 <a:solidFill>
                   <a:srgbClr val="FFFFFF"/>
                 </a:solidFill>
@@ -9326,7 +9326,7 @@
           <a:p>
             <a:pPr algn="l"/>
             <a:r>
-              <a:rPr sz="1250" b="1" i="0" u="none">
+              <a:rPr sz="1500" b="1" i="0" u="none">
                 <a:solidFill>
                   <a:srgbClr val="1B2A41"/>
                 </a:solidFill>
@@ -9361,7 +9361,7 @@
           <a:p>
             <a:pPr algn="l"/>
             <a:r>
-              <a:rPr sz="1050" b="0" i="0" u="none">
+              <a:rPr sz="1250" b="0" i="0" u="none">
                 <a:solidFill>
                   <a:srgbClr val="5B6778"/>
                 </a:solidFill>
@@ -9490,7 +9490,7 @@
           <a:p>
             <a:pPr algn="ctr"/>
             <a:r>
-              <a:rPr sz="1500" b="1" i="0" u="none">
+              <a:rPr sz="1750" b="1" i="0" u="none">
                 <a:solidFill>
                   <a:srgbClr val="FFFFFF"/>
                 </a:solidFill>
@@ -9525,7 +9525,7 @@
           <a:p>
             <a:pPr algn="l"/>
             <a:r>
-              <a:rPr sz="1250" b="1" i="0" u="none">
+              <a:rPr sz="1500" b="1" i="0" u="none">
                 <a:solidFill>
                   <a:srgbClr val="1B2A41"/>
                 </a:solidFill>
@@ -9560,7 +9560,7 @@
           <a:p>
             <a:pPr algn="l"/>
             <a:r>
-              <a:rPr sz="1050" b="0" i="0" u="none">
+              <a:rPr sz="1250" b="0" i="0" u="none">
                 <a:solidFill>
                   <a:srgbClr val="5B6778"/>
                 </a:solidFill>
@@ -9689,7 +9689,7 @@
           <a:p>
             <a:pPr algn="ctr"/>
             <a:r>
-              <a:rPr sz="1500" b="1" i="0" u="none">
+              <a:rPr sz="1750" b="1" i="0" u="none">
                 <a:solidFill>
                   <a:srgbClr val="FFFFFF"/>
                 </a:solidFill>
@@ -9724,7 +9724,7 @@
           <a:p>
             <a:pPr algn="l"/>
             <a:r>
-              <a:rPr sz="1250" b="1" i="0" u="none">
+              <a:rPr sz="1500" b="1" i="0" u="none">
                 <a:solidFill>
                   <a:srgbClr val="1B2A41"/>
                 </a:solidFill>
@@ -9759,7 +9759,7 @@
           <a:p>
             <a:pPr algn="l"/>
             <a:r>
-              <a:rPr sz="1050" b="0" i="0" u="none">
+              <a:rPr sz="1250" b="0" i="0" u="none">
                 <a:solidFill>
                   <a:srgbClr val="5B6778"/>
                 </a:solidFill>
@@ -9888,7 +9888,7 @@
           <a:p>
             <a:pPr algn="ctr"/>
             <a:r>
-              <a:rPr sz="1500" b="1" i="0" u="none">
+              <a:rPr sz="1750" b="1" i="0" u="none">
                 <a:solidFill>
                   <a:srgbClr val="FFFFFF"/>
                 </a:solidFill>
@@ -9923,7 +9923,7 @@
           <a:p>
             <a:pPr algn="l"/>
             <a:r>
-              <a:rPr sz="1250" b="1" i="0" u="none">
+              <a:rPr sz="1500" b="1" i="0" u="none">
                 <a:solidFill>
                   <a:srgbClr val="1B2A41"/>
                 </a:solidFill>
@@ -9958,7 +9958,7 @@
           <a:p>
             <a:pPr algn="l"/>
             <a:r>
-              <a:rPr sz="1050" b="0" i="0" u="none">
+              <a:rPr sz="1250" b="0" i="0" u="none">
                 <a:solidFill>
                   <a:srgbClr val="5B6778"/>
                 </a:solidFill>
@@ -10087,7 +10087,7 @@
           <a:p>
             <a:pPr algn="ctr"/>
             <a:r>
-              <a:rPr sz="1500" b="1" i="0" u="none">
+              <a:rPr sz="1750" b="1" i="0" u="none">
                 <a:solidFill>
                   <a:srgbClr val="FFFFFF"/>
                 </a:solidFill>
@@ -10122,7 +10122,7 @@
           <a:p>
             <a:pPr algn="l"/>
             <a:r>
-              <a:rPr sz="1250" b="1" i="0" u="none">
+              <a:rPr sz="1500" b="1" i="0" u="none">
                 <a:solidFill>
                   <a:srgbClr val="1B2A41"/>
                 </a:solidFill>
@@ -10157,7 +10157,7 @@
           <a:p>
             <a:pPr algn="l"/>
             <a:r>
-              <a:rPr sz="1050" b="0" i="0" u="none">
+              <a:rPr sz="1250" b="0" i="0" u="none">
                 <a:solidFill>
                   <a:srgbClr val="5B6778"/>
                 </a:solidFill>
@@ -10286,7 +10286,7 @@
           <a:p>
             <a:pPr algn="ctr"/>
             <a:r>
-              <a:rPr sz="1500" b="1" i="0" u="none">
+              <a:rPr sz="1750" b="1" i="0" u="none">
                 <a:solidFill>
                   <a:srgbClr val="FFFFFF"/>
                 </a:solidFill>
@@ -10321,7 +10321,7 @@
           <a:p>
             <a:pPr algn="l"/>
             <a:r>
-              <a:rPr sz="1250" b="1" i="0" u="none">
+              <a:rPr sz="1500" b="1" i="0" u="none">
                 <a:solidFill>
                   <a:srgbClr val="1B2A41"/>
                 </a:solidFill>
@@ -10356,7 +10356,7 @@
           <a:p>
             <a:pPr algn="l"/>
             <a:r>
-              <a:rPr sz="1050" b="0" i="0" u="none">
+              <a:rPr sz="1250" b="0" i="0" u="none">
                 <a:solidFill>
                   <a:srgbClr val="5B6778"/>
                 </a:solidFill>
@@ -10391,7 +10391,7 @@
           <a:p>
             <a:pPr algn="l"/>
             <a:r>
-              <a:rPr sz="1300" b="1" i="0" u="none">
+              <a:rPr sz="1550" b="1" i="0" u="none">
                 <a:solidFill>
                   <a:srgbClr val="0B7468"/>
                 </a:solidFill>
@@ -10403,7 +10403,7 @@
           <a:p>
             <a:pPr algn="l"/>
             <a:r>
-              <a:rPr sz="1300" b="1" i="0" u="none">
+              <a:rPr sz="1550" b="1" i="0" u="none">
                 <a:solidFill>
                   <a:srgbClr val="0B7468"/>
                 </a:solidFill>
@@ -10486,7 +10486,7 @@
           <a:p>
             <a:pPr algn="ctr"/>
             <a:r>
-              <a:rPr sz="1100" b="1" i="0" u="none">
+              <a:rPr sz="1300" b="1" i="0" u="none">
                 <a:solidFill>
                   <a:srgbClr val="FFFFFF"/>
                 </a:solidFill>
@@ -10498,7 +10498,7 @@
           <a:p>
             <a:pPr algn="ctr"/>
             <a:r>
-              <a:rPr sz="900" b="0" i="0" u="none">
+              <a:rPr sz="1050" b="0" i="0" u="none">
                 <a:solidFill>
                   <a:srgbClr val="FFFFFF"/>
                 </a:solidFill>
@@ -10581,7 +10581,7 @@
           <a:p>
             <a:pPr algn="ctr"/>
             <a:r>
-              <a:rPr sz="1100" b="1" i="0" u="none">
+              <a:rPr sz="1300" b="1" i="0" u="none">
                 <a:solidFill>
                   <a:srgbClr val="FFFFFF"/>
                 </a:solidFill>
@@ -10593,7 +10593,7 @@
           <a:p>
             <a:pPr algn="ctr"/>
             <a:r>
-              <a:rPr sz="900" b="0" i="0" u="none">
+              <a:rPr sz="1050" b="0" i="0" u="none">
                 <a:solidFill>
                   <a:srgbClr val="FFFFFF"/>
                 </a:solidFill>
@@ -10676,7 +10676,7 @@
           <a:p>
             <a:pPr algn="ctr"/>
             <a:r>
-              <a:rPr sz="1100" b="1" i="0" u="none">
+              <a:rPr sz="1300" b="1" i="0" u="none">
                 <a:solidFill>
                   <a:srgbClr val="FFFFFF"/>
                 </a:solidFill>
@@ -10688,7 +10688,7 @@
           <a:p>
             <a:pPr algn="ctr"/>
             <a:r>
-              <a:rPr sz="900" b="0" i="0" u="none">
+              <a:rPr sz="1050" b="0" i="0" u="none">
                 <a:solidFill>
                   <a:srgbClr val="FFFFFF"/>
                 </a:solidFill>
@@ -10771,7 +10771,7 @@
           <a:p>
             <a:pPr algn="ctr"/>
             <a:r>
-              <a:rPr sz="1100" b="1" i="0" u="none">
+              <a:rPr sz="1300" b="1" i="0" u="none">
                 <a:solidFill>
                   <a:srgbClr val="FFFFFF"/>
                 </a:solidFill>
@@ -10783,7 +10783,7 @@
           <a:p>
             <a:pPr algn="ctr"/>
             <a:r>
-              <a:rPr sz="900" b="0" i="0" u="none">
+              <a:rPr sz="1050" b="0" i="0" u="none">
                 <a:solidFill>
                   <a:srgbClr val="FFFFFF"/>
                 </a:solidFill>
@@ -10866,7 +10866,7 @@
           <a:p>
             <a:pPr algn="ctr"/>
             <a:r>
-              <a:rPr sz="1100" b="1" i="0" u="none">
+              <a:rPr sz="1300" b="1" i="0" u="none">
                 <a:solidFill>
                   <a:srgbClr val="FFFFFF"/>
                 </a:solidFill>
@@ -10878,7 +10878,7 @@
           <a:p>
             <a:pPr algn="ctr"/>
             <a:r>
-              <a:rPr sz="900" b="0" i="0" u="none">
+              <a:rPr sz="1050" b="0" i="0" u="none">
                 <a:solidFill>
                   <a:srgbClr val="FFFFFF"/>
                 </a:solidFill>
@@ -10961,7 +10961,7 @@
           <a:p>
             <a:pPr algn="ctr"/>
             <a:r>
-              <a:rPr sz="1100" b="1" i="0" u="none">
+              <a:rPr sz="1300" b="1" i="0" u="none">
                 <a:solidFill>
                   <a:srgbClr val="FFFFFF"/>
                 </a:solidFill>
@@ -10973,7 +10973,7 @@
           <a:p>
             <a:pPr algn="ctr"/>
             <a:r>
-              <a:rPr sz="900" b="0" i="0" u="none">
+              <a:rPr sz="1050" b="0" i="0" u="none">
                 <a:solidFill>
                   <a:srgbClr val="FFFFFF"/>
                 </a:solidFill>
@@ -11056,7 +11056,7 @@
           <a:p>
             <a:pPr algn="ctr"/>
             <a:r>
-              <a:rPr sz="1100" b="1" i="0" u="none">
+              <a:rPr sz="1300" b="1" i="0" u="none">
                 <a:solidFill>
                   <a:srgbClr val="FFFFFF"/>
                 </a:solidFill>
@@ -11068,7 +11068,7 @@
           <a:p>
             <a:pPr algn="ctr"/>
             <a:r>
-              <a:rPr sz="900" b="0" i="0" u="none">
+              <a:rPr sz="1050" b="0" i="0" u="none">
                 <a:solidFill>
                   <a:srgbClr val="FFFFFF"/>
                 </a:solidFill>
@@ -11708,7 +11708,7 @@
           <a:p>
             <a:pPr algn="l"/>
             <a:r>
-              <a:rPr sz="1700" b="1" i="0" u="none">
+              <a:rPr sz="2000" b="1" i="0" u="none">
                 <a:solidFill>
                   <a:srgbClr val="1B2A41"/>
                 </a:solidFill>
@@ -11743,7 +11743,7 @@
           <a:p>
             <a:pPr algn="l"/>
             <a:r>
-              <a:rPr sz="1050" b="0" i="1" u="none">
+              <a:rPr sz="1250" b="0" i="1" u="none">
                 <a:solidFill>
                   <a:srgbClr val="1F497D"/>
                 </a:solidFill>
@@ -11778,7 +11778,7 @@
           <a:p>
             <a:pPr algn="l"/>
             <a:r>
-              <a:rPr sz="1050" b="1" i="0" u="none">
+              <a:rPr sz="1250" b="1" i="0" u="none">
                 <a:solidFill>
                   <a:srgbClr val="2A6FB0"/>
                 </a:solidFill>
@@ -11787,7 +11787,7 @@
               <a:t>SENSE &amp; UNDERSTAND  </a:t>
             </a:r>
             <a:r>
-              <a:rPr sz="950" b="0" i="0" u="none">
+              <a:rPr sz="1100" b="0" i="0" u="none">
                 <a:solidFill>
                   <a:srgbClr val="5B6778"/>
                 </a:solidFill>
@@ -11796,7 +11796,7 @@
               <a:t>→ row 1</a:t>
             </a:r>
             <a:r>
-              <a:rPr sz="1050" b="1" i="0" u="none">
+              <a:rPr sz="1250" b="1" i="0" u="none">
                 <a:solidFill>
                   <a:srgbClr val="0B7468"/>
                 </a:solidFill>
@@ -11805,7 +11805,7 @@
               <a:t>          PLAN &amp; DECIDE  </a:t>
             </a:r>
             <a:r>
-              <a:rPr sz="950" b="0" i="0" u="none">
+              <a:rPr sz="1100" b="0" i="0" u="none">
                 <a:solidFill>
                   <a:srgbClr val="5B6778"/>
                 </a:solidFill>
@@ -11958,7 +11958,7 @@
           <a:p>
             <a:pPr algn="r"/>
             <a:r>
-              <a:rPr sz="900" b="1" i="0" u="none">
+              <a:rPr sz="1050" b="1" i="0" u="none">
                 <a:solidFill>
                   <a:srgbClr val="1F497D"/>
                 </a:solidFill>
@@ -11993,7 +11993,7 @@
           <a:p>
             <a:pPr algn="l"/>
             <a:r>
-              <a:rPr sz="1050" b="1" i="0" u="none">
+              <a:rPr sz="1250" b="1" i="0" u="none">
                 <a:solidFill>
                   <a:srgbClr val="1B2A41"/>
                 </a:solidFill>
@@ -12028,7 +12028,7 @@
           <a:p>
             <a:pPr algn="l"/>
             <a:r>
-              <a:rPr sz="950" b="0" i="0" u="none">
+              <a:rPr sz="1100" b="0" i="0" u="none">
                 <a:solidFill>
                   <a:srgbClr val="5B6778"/>
                 </a:solidFill>
@@ -12181,7 +12181,7 @@
           <a:p>
             <a:pPr algn="r"/>
             <a:r>
-              <a:rPr sz="900" b="1" i="0" u="none">
+              <a:rPr sz="1050" b="1" i="0" u="none">
                 <a:solidFill>
                   <a:srgbClr val="245C93"/>
                 </a:solidFill>
@@ -12216,7 +12216,7 @@
           <a:p>
             <a:pPr algn="l"/>
             <a:r>
-              <a:rPr sz="1050" b="1" i="0" u="none">
+              <a:rPr sz="1250" b="1" i="0" u="none">
                 <a:solidFill>
                   <a:srgbClr val="1B2A41"/>
                 </a:solidFill>
@@ -12251,7 +12251,7 @@
           <a:p>
             <a:pPr algn="l"/>
             <a:r>
-              <a:rPr sz="950" b="0" i="0" u="none">
+              <a:rPr sz="1100" b="0" i="0" u="none">
                 <a:solidFill>
                   <a:srgbClr val="5B6778"/>
                 </a:solidFill>
@@ -12404,7 +12404,7 @@
           <a:p>
             <a:pPr algn="r"/>
             <a:r>
-              <a:rPr sz="900" b="1" i="0" u="none">
+              <a:rPr sz="1050" b="1" i="0" u="none">
                 <a:solidFill>
                   <a:srgbClr val="2A6FB0"/>
                 </a:solidFill>
@@ -12439,7 +12439,7 @@
           <a:p>
             <a:pPr algn="l"/>
             <a:r>
-              <a:rPr sz="1050" b="1" i="0" u="none">
+              <a:rPr sz="1250" b="1" i="0" u="none">
                 <a:solidFill>
                   <a:srgbClr val="1B2A41"/>
                 </a:solidFill>
@@ -12474,7 +12474,7 @@
           <a:p>
             <a:pPr algn="l"/>
             <a:r>
-              <a:rPr sz="950" b="0" i="0" u="none">
+              <a:rPr sz="1100" b="0" i="0" u="none">
                 <a:solidFill>
                   <a:srgbClr val="5B6778"/>
                 </a:solidFill>
@@ -12627,7 +12627,7 @@
           <a:p>
             <a:pPr algn="r"/>
             <a:r>
-              <a:rPr sz="900" b="1" i="0" u="none">
+              <a:rPr sz="1050" b="1" i="0" u="none">
                 <a:solidFill>
                   <a:srgbClr val="1B82A0"/>
                 </a:solidFill>
@@ -12662,7 +12662,7 @@
           <a:p>
             <a:pPr algn="l"/>
             <a:r>
-              <a:rPr sz="1050" b="1" i="0" u="none">
+              <a:rPr sz="1250" b="1" i="0" u="none">
                 <a:solidFill>
                   <a:srgbClr val="1B2A41"/>
                 </a:solidFill>
@@ -12697,7 +12697,7 @@
           <a:p>
             <a:pPr algn="l"/>
             <a:r>
-              <a:rPr sz="950" b="0" i="0" u="none">
+              <a:rPr sz="1100" b="0" i="0" u="none">
                 <a:solidFill>
                   <a:srgbClr val="5B6778"/>
                 </a:solidFill>
@@ -12850,7 +12850,7 @@
           <a:p>
             <a:pPr algn="r"/>
             <a:r>
-              <a:rPr sz="900" b="1" i="0" u="none">
+              <a:rPr sz="1050" b="1" i="0" u="none">
                 <a:solidFill>
                   <a:srgbClr val="118F95"/>
                 </a:solidFill>
@@ -12885,7 +12885,7 @@
           <a:p>
             <a:pPr algn="l"/>
             <a:r>
-              <a:rPr sz="1050" b="1" i="0" u="none">
+              <a:rPr sz="1250" b="1" i="0" u="none">
                 <a:solidFill>
                   <a:srgbClr val="1B2A41"/>
                 </a:solidFill>
@@ -12920,7 +12920,7 @@
           <a:p>
             <a:pPr algn="l"/>
             <a:r>
-              <a:rPr sz="950" b="0" i="0" u="none">
+              <a:rPr sz="1100" b="0" i="0" u="none">
                 <a:solidFill>
                   <a:srgbClr val="5B6778"/>
                 </a:solidFill>
@@ -13073,7 +13073,7 @@
           <a:p>
             <a:pPr algn="r"/>
             <a:r>
-              <a:rPr sz="900" b="1" i="0" u="none">
+              <a:rPr sz="1050" b="1" i="0" u="none">
                 <a:solidFill>
                   <a:srgbClr val="0F9E8E"/>
                 </a:solidFill>
@@ -13108,7 +13108,7 @@
           <a:p>
             <a:pPr algn="l"/>
             <a:r>
-              <a:rPr sz="1050" b="1" i="0" u="none">
+              <a:rPr sz="1250" b="1" i="0" u="none">
                 <a:solidFill>
                   <a:srgbClr val="1B2A41"/>
                 </a:solidFill>
@@ -13143,7 +13143,7 @@
           <a:p>
             <a:pPr algn="l"/>
             <a:r>
-              <a:rPr sz="950" b="0" i="0" u="none">
+              <a:rPr sz="1100" b="0" i="0" u="none">
                 <a:solidFill>
                   <a:srgbClr val="5B6778"/>
                 </a:solidFill>
@@ -13296,7 +13296,7 @@
           <a:p>
             <a:pPr algn="r"/>
             <a:r>
-              <a:rPr sz="900" b="1" i="0" u="none">
+              <a:rPr sz="1050" b="1" i="0" u="none">
                 <a:solidFill>
                   <a:srgbClr val="0F9E8E"/>
                 </a:solidFill>
@@ -13331,7 +13331,7 @@
           <a:p>
             <a:pPr algn="l"/>
             <a:r>
-              <a:rPr sz="1050" b="1" i="0" u="none">
+              <a:rPr sz="1250" b="1" i="0" u="none">
                 <a:solidFill>
                   <a:srgbClr val="1B2A41"/>
                 </a:solidFill>
@@ -13366,7 +13366,7 @@
           <a:p>
             <a:pPr algn="l"/>
             <a:r>
-              <a:rPr sz="950" b="0" i="0" u="none">
+              <a:rPr sz="1100" b="0" i="0" u="none">
                 <a:solidFill>
                   <a:srgbClr val="5B6778"/>
                 </a:solidFill>
@@ -13519,7 +13519,7 @@
           <a:p>
             <a:pPr algn="r"/>
             <a:r>
-              <a:rPr sz="900" b="1" i="0" u="none">
+              <a:rPr sz="1050" b="1" i="0" u="none">
                 <a:solidFill>
                   <a:srgbClr val="0B7468"/>
                 </a:solidFill>
@@ -13554,7 +13554,7 @@
           <a:p>
             <a:pPr algn="l"/>
             <a:r>
-              <a:rPr sz="1050" b="1" i="0" u="none">
+              <a:rPr sz="1250" b="1" i="0" u="none">
                 <a:solidFill>
                   <a:srgbClr val="1B2A41"/>
                 </a:solidFill>
@@ -13589,7 +13589,7 @@
           <a:p>
             <a:pPr algn="l"/>
             <a:r>
-              <a:rPr sz="950" b="0" i="0" u="none">
+              <a:rPr sz="1100" b="0" i="0" u="none">
                 <a:solidFill>
                   <a:srgbClr val="5B6778"/>
                 </a:solidFill>
@@ -13742,7 +13742,7 @@
           <a:p>
             <a:pPr algn="r"/>
             <a:r>
-              <a:rPr sz="900" b="1" i="0" u="none">
+              <a:rPr sz="1050" b="1" i="0" u="none">
                 <a:solidFill>
                   <a:srgbClr val="0B7468"/>
                 </a:solidFill>
@@ -13777,7 +13777,7 @@
           <a:p>
             <a:pPr algn="l"/>
             <a:r>
-              <a:rPr sz="1050" b="1" i="0" u="none">
+              <a:rPr sz="1250" b="1" i="0" u="none">
                 <a:solidFill>
                   <a:srgbClr val="1B2A41"/>
                 </a:solidFill>
@@ -13812,7 +13812,7 @@
           <a:p>
             <a:pPr algn="l"/>
             <a:r>
-              <a:rPr sz="950" b="0" i="0" u="none">
+              <a:rPr sz="1100" b="0" i="0" u="none">
                 <a:solidFill>
                   <a:srgbClr val="5B6778"/>
                 </a:solidFill>
@@ -13965,7 +13965,7 @@
           <a:p>
             <a:pPr algn="r"/>
             <a:r>
-              <a:rPr sz="900" b="1" i="0" u="none">
+              <a:rPr sz="1050" b="1" i="0" u="none">
                 <a:solidFill>
                   <a:srgbClr val="16A34A"/>
                 </a:solidFill>
@@ -14000,7 +14000,7 @@
           <a:p>
             <a:pPr algn="l"/>
             <a:r>
-              <a:rPr sz="1050" b="1" i="0" u="none">
+              <a:rPr sz="1250" b="1" i="0" u="none">
                 <a:solidFill>
                   <a:srgbClr val="1B2A41"/>
                 </a:solidFill>
@@ -14035,7 +14035,7 @@
           <a:p>
             <a:pPr algn="l"/>
             <a:r>
-              <a:rPr sz="950" b="0" i="0" u="none">
+              <a:rPr sz="1100" b="0" i="0" u="none">
                 <a:solidFill>
                   <a:srgbClr val="5B6778"/>
                 </a:solidFill>
@@ -14474,7 +14474,7 @@
           <a:p>
             <a:pPr algn="l"/>
             <a:r>
-              <a:rPr sz="1050" b="1" i="0" u="none">
+              <a:rPr sz="1250" b="1" i="0" u="none">
                 <a:solidFill>
                   <a:srgbClr val="0B7468"/>
                 </a:solidFill>
@@ -14557,7 +14557,7 @@
           <a:p>
             <a:pPr algn="l"/>
             <a:r>
-              <a:rPr sz="1150" b="1" i="0" u="none">
+              <a:rPr sz="1350" b="1" i="0" u="none">
                 <a:solidFill>
                   <a:srgbClr val="1B2A41"/>
                 </a:solidFill>
@@ -14638,7 +14638,7 @@
           <a:p>
             <a:pPr algn="ctr"/>
             <a:r>
-              <a:rPr sz="1050" b="1" i="0" u="none">
+              <a:rPr sz="1250" b="1" i="0" u="none">
                 <a:solidFill>
                   <a:srgbClr val="FFFFFF"/>
                 </a:solidFill>
@@ -14673,7 +14673,7 @@
           <a:p>
             <a:pPr algn="l"/>
             <a:r>
-              <a:rPr sz="1050" b="0" i="0" u="none">
+              <a:rPr sz="1250" b="0" i="0" u="none">
                 <a:solidFill>
                   <a:srgbClr val="243044"/>
                 </a:solidFill>
@@ -14754,7 +14754,7 @@
           <a:p>
             <a:pPr algn="ctr"/>
             <a:r>
-              <a:rPr sz="1050" b="1" i="0" u="none">
+              <a:rPr sz="1250" b="1" i="0" u="none">
                 <a:solidFill>
                   <a:srgbClr val="FFFFFF"/>
                 </a:solidFill>
@@ -14789,7 +14789,7 @@
           <a:p>
             <a:pPr algn="l"/>
             <a:r>
-              <a:rPr sz="1050" b="0" i="0" u="none">
+              <a:rPr sz="1250" b="0" i="0" u="none">
                 <a:solidFill>
                   <a:srgbClr val="243044"/>
                 </a:solidFill>
@@ -14870,7 +14870,7 @@
           <a:p>
             <a:pPr algn="ctr"/>
             <a:r>
-              <a:rPr sz="1050" b="1" i="0" u="none">
+              <a:rPr sz="1250" b="1" i="0" u="none">
                 <a:solidFill>
                   <a:srgbClr val="FFFFFF"/>
                 </a:solidFill>
@@ -14905,7 +14905,7 @@
           <a:p>
             <a:pPr algn="l"/>
             <a:r>
-              <a:rPr sz="1050" b="0" i="0" u="none">
+              <a:rPr sz="1250" b="0" i="0" u="none">
                 <a:solidFill>
                   <a:srgbClr val="243044"/>
                 </a:solidFill>
@@ -14986,7 +14986,7 @@
           <a:p>
             <a:pPr algn="ctr"/>
             <a:r>
-              <a:rPr sz="1050" b="1" i="0" u="none">
+              <a:rPr sz="1250" b="1" i="0" u="none">
                 <a:solidFill>
                   <a:srgbClr val="FFFFFF"/>
                 </a:solidFill>
@@ -15021,7 +15021,7 @@
           <a:p>
             <a:pPr algn="l"/>
             <a:r>
-              <a:rPr sz="1050" b="0" i="0" u="none">
+              <a:rPr sz="1250" b="0" i="0" u="none">
                 <a:solidFill>
                   <a:srgbClr val="243044"/>
                 </a:solidFill>
@@ -15102,7 +15102,7 @@
           <a:p>
             <a:pPr algn="ctr"/>
             <a:r>
-              <a:rPr sz="1050" b="1" i="0" u="none">
+              <a:rPr sz="1250" b="1" i="0" u="none">
                 <a:solidFill>
                   <a:srgbClr val="FFFFFF"/>
                 </a:solidFill>
@@ -15137,7 +15137,7 @@
           <a:p>
             <a:pPr algn="l"/>
             <a:r>
-              <a:rPr sz="1050" b="0" i="0" u="none">
+              <a:rPr sz="1250" b="0" i="0" u="none">
                 <a:solidFill>
                   <a:srgbClr val="243044"/>
                 </a:solidFill>
@@ -15249,7 +15249,7 @@
           <a:p>
             <a:pPr algn="l"/>
             <a:r>
-              <a:rPr sz="950" b="0" i="1" u="none">
+              <a:rPr sz="1100" b="0" i="1" u="none">
                 <a:solidFill>
                   <a:srgbClr val="5B6778"/>
                 </a:solidFill>
@@ -15354,7 +15354,7 @@
           <a:p>
             <a:pPr algn="l"/>
             <a:r>
-              <a:rPr sz="1700" b="1" i="0" u="none">
+              <a:rPr sz="2000" b="1" i="0" u="none">
                 <a:solidFill>
                   <a:srgbClr val="1B2A41"/>
                 </a:solidFill>
@@ -15389,7 +15389,7 @@
           <a:p>
             <a:pPr algn="l"/>
             <a:r>
-              <a:rPr sz="1050" b="0" i="1" u="none">
+              <a:rPr sz="1250" b="0" i="1" u="none">
                 <a:solidFill>
                   <a:srgbClr val="1F497D"/>
                 </a:solidFill>
@@ -15496,7 +15496,7 @@
           <a:p>
             <a:pPr algn="l"/>
             <a:r>
-              <a:rPr sz="1250" b="1" i="0" u="none">
+              <a:rPr sz="1500" b="1" i="0" u="none">
                 <a:solidFill>
                   <a:srgbClr val="1B2A41"/>
                 </a:solidFill>
@@ -15531,7 +15531,7 @@
           <a:p>
             <a:pPr algn="l"/>
             <a:r>
-              <a:rPr sz="1000" b="0" i="0" u="none">
+              <a:rPr sz="1200" b="0" i="0" u="none">
                 <a:solidFill>
                   <a:srgbClr val="5B6778"/>
                 </a:solidFill>
@@ -15638,7 +15638,7 @@
           <a:p>
             <a:pPr algn="l"/>
             <a:r>
-              <a:rPr sz="1250" b="1" i="0" u="none">
+              <a:rPr sz="1500" b="1" i="0" u="none">
                 <a:solidFill>
                   <a:srgbClr val="1B2A41"/>
                 </a:solidFill>
@@ -15673,7 +15673,7 @@
           <a:p>
             <a:pPr algn="l"/>
             <a:r>
-              <a:rPr sz="1000" b="0" i="0" u="none">
+              <a:rPr sz="1200" b="0" i="0" u="none">
                 <a:solidFill>
                   <a:srgbClr val="5B6778"/>
                 </a:solidFill>
@@ -15780,7 +15780,7 @@
           <a:p>
             <a:pPr algn="l"/>
             <a:r>
-              <a:rPr sz="1250" b="1" i="0" u="none">
+              <a:rPr sz="1500" b="1" i="0" u="none">
                 <a:solidFill>
                   <a:srgbClr val="1B2A41"/>
                 </a:solidFill>
@@ -15815,7 +15815,7 @@
           <a:p>
             <a:pPr algn="l"/>
             <a:r>
-              <a:rPr sz="1000" b="0" i="0" u="none">
+              <a:rPr sz="1200" b="0" i="0" u="none">
                 <a:solidFill>
                   <a:srgbClr val="5B6778"/>
                 </a:solidFill>
@@ -15922,7 +15922,7 @@
           <a:p>
             <a:pPr algn="l"/>
             <a:r>
-              <a:rPr sz="1250" b="1" i="0" u="none">
+              <a:rPr sz="1500" b="1" i="0" u="none">
                 <a:solidFill>
                   <a:srgbClr val="1B2A41"/>
                 </a:solidFill>
@@ -15957,7 +15957,7 @@
           <a:p>
             <a:pPr algn="l"/>
             <a:r>
-              <a:rPr sz="1000" b="0" i="0" u="none">
+              <a:rPr sz="1200" b="0" i="0" u="none">
                 <a:solidFill>
                   <a:srgbClr val="5B6778"/>
                 </a:solidFill>
@@ -16110,7 +16110,7 @@
           <a:p>
             <a:pPr algn="l"/>
             <a:r>
-              <a:rPr sz="1250" b="1" i="0" u="none">
+              <a:rPr sz="1500" b="1" i="0" u="none">
                 <a:solidFill>
                   <a:srgbClr val="1B2A41"/>
                 </a:solidFill>
@@ -16145,7 +16145,7 @@
           <a:p>
             <a:pPr algn="l"/>
             <a:r>
-              <a:rPr sz="1000" b="0" i="0" u="none">
+              <a:rPr sz="1200" b="0" i="0" u="none">
                 <a:solidFill>
                   <a:srgbClr val="5B6778"/>
                 </a:solidFill>
@@ -16298,7 +16298,7 @@
           <a:p>
             <a:pPr algn="l"/>
             <a:r>
-              <a:rPr sz="1100" b="1" i="0" u="none">
+              <a:rPr sz="1300" b="1" i="0" u="none">
                 <a:solidFill>
                   <a:srgbClr val="1B2A41"/>
                 </a:solidFill>
@@ -16333,7 +16333,7 @@
           <a:p>
             <a:pPr algn="l"/>
             <a:r>
-              <a:rPr sz="1000" b="0" i="0" u="none">
+              <a:rPr sz="1200" b="0" i="0" u="none">
                 <a:solidFill>
                   <a:srgbClr val="5B6778"/>
                 </a:solidFill>
@@ -16440,7 +16440,7 @@
           <a:p>
             <a:pPr algn="l"/>
             <a:r>
-              <a:rPr sz="1250" b="1" i="0" u="none">
+              <a:rPr sz="1500" b="1" i="0" u="none">
                 <a:solidFill>
                   <a:srgbClr val="1B2A41"/>
                 </a:solidFill>
@@ -16475,7 +16475,7 @@
           <a:p>
             <a:pPr algn="l"/>
             <a:r>
-              <a:rPr sz="1000" b="0" i="0" u="none">
+              <a:rPr sz="1200" b="0" i="0" u="none">
                 <a:solidFill>
                   <a:srgbClr val="5B6778"/>
                 </a:solidFill>
@@ -16582,7 +16582,7 @@
           <a:p>
             <a:pPr algn="l"/>
             <a:r>
-              <a:rPr sz="1250" b="1" i="0" u="none">
+              <a:rPr sz="1500" b="1" i="0" u="none">
                 <a:solidFill>
                   <a:srgbClr val="1B2A41"/>
                 </a:solidFill>
@@ -16617,7 +16617,7 @@
           <a:p>
             <a:pPr algn="l"/>
             <a:r>
-              <a:rPr sz="1000" b="0" i="0" u="none">
+              <a:rPr sz="1200" b="0" i="0" u="none">
                 <a:solidFill>
                   <a:srgbClr val="5B6778"/>
                 </a:solidFill>
@@ -16724,7 +16724,7 @@
           <a:p>
             <a:pPr algn="l"/>
             <a:r>
-              <a:rPr sz="1250" b="1" i="0" u="none">
+              <a:rPr sz="1500" b="1" i="0" u="none">
                 <a:solidFill>
                   <a:srgbClr val="1B2A41"/>
                 </a:solidFill>
@@ -16759,7 +16759,7 @@
           <a:p>
             <a:pPr algn="l"/>
             <a:r>
-              <a:rPr sz="1000" b="0" i="0" u="none">
+              <a:rPr sz="1200" b="0" i="0" u="none">
                 <a:solidFill>
                   <a:srgbClr val="5B6778"/>
                 </a:solidFill>
@@ -16914,7 +16914,7 @@
           <a:p>
             <a:pPr algn="l"/>
             <a:r>
-              <a:rPr sz="1100" b="1" i="0" u="none">
+              <a:rPr sz="1300" b="1" i="0" u="none">
                 <a:solidFill>
                   <a:srgbClr val="1B2A41"/>
                 </a:solidFill>
@@ -16949,7 +16949,7 @@
           <a:p>
             <a:pPr algn="l"/>
             <a:r>
-              <a:rPr sz="1000" b="0" i="0" u="none">
+              <a:rPr sz="1200" b="0" i="0" u="none">
                 <a:solidFill>
                   <a:srgbClr val="5B6778"/>
                 </a:solidFill>
@@ -17621,7 +17621,7 @@
           <a:p>
             <a:pPr algn="l"/>
             <a:r>
-              <a:rPr sz="1700" b="1" i="0" u="none">
+              <a:rPr sz="2000" b="1" i="0" u="none">
                 <a:solidFill>
                   <a:srgbClr val="1B2A41"/>
                 </a:solidFill>
@@ -17656,7 +17656,7 @@
           <a:p>
             <a:pPr algn="l"/>
             <a:r>
-              <a:rPr sz="1050" b="0" i="1" u="none">
+              <a:rPr sz="1250" b="0" i="1" u="none">
                 <a:solidFill>
                   <a:srgbClr val="1F497D"/>
                 </a:solidFill>
@@ -17737,7 +17737,7 @@
           <a:p>
             <a:pPr algn="l"/>
             <a:r>
-              <a:rPr sz="1200" b="1" i="0" u="none">
+              <a:rPr sz="1400" b="1" i="0" u="none">
                 <a:solidFill>
                   <a:srgbClr val="FFFFFF"/>
                 </a:solidFill>
@@ -17746,7 +17746,7 @@
               <a:t>1  </a:t>
             </a:r>
             <a:r>
-              <a:rPr sz="1300" b="1" i="0" u="none">
+              <a:rPr sz="1550" b="1" i="0" u="none">
                 <a:solidFill>
                   <a:srgbClr val="FFFFFF"/>
                 </a:solidFill>
@@ -17810,7 +17810,7 @@
           <a:p>
             <a:pPr algn="l"/>
             <a:r>
-              <a:rPr sz="1100" b="0" i="0" u="none">
+              <a:rPr sz="1300" b="0" i="0" u="none">
                 <a:solidFill>
                   <a:srgbClr val="243044"/>
                 </a:solidFill>
@@ -17927,7 +17927,7 @@
           <a:p>
             <a:pPr algn="l"/>
             <a:r>
-              <a:rPr sz="1200" b="1" i="0" u="none">
+              <a:rPr sz="1400" b="1" i="0" u="none">
                 <a:solidFill>
                   <a:srgbClr val="FFFFFF"/>
                 </a:solidFill>
@@ -17936,7 +17936,7 @@
               <a:t>2  </a:t>
             </a:r>
             <a:r>
-              <a:rPr sz="1300" b="1" i="0" u="none">
+              <a:rPr sz="1550" b="1" i="0" u="none">
                 <a:solidFill>
                   <a:srgbClr val="FFFFFF"/>
                 </a:solidFill>
@@ -18000,7 +18000,7 @@
           <a:p>
             <a:pPr algn="l"/>
             <a:r>
-              <a:rPr sz="1100" b="0" i="0" u="none">
+              <a:rPr sz="1300" b="0" i="0" u="none">
                 <a:solidFill>
                   <a:srgbClr val="243044"/>
                 </a:solidFill>
@@ -18117,7 +18117,7 @@
           <a:p>
             <a:pPr algn="l"/>
             <a:r>
-              <a:rPr sz="1200" b="1" i="0" u="none">
+              <a:rPr sz="1400" b="1" i="0" u="none">
                 <a:solidFill>
                   <a:srgbClr val="FFFFFF"/>
                 </a:solidFill>
@@ -18126,7 +18126,7 @@
               <a:t>3  </a:t>
             </a:r>
             <a:r>
-              <a:rPr sz="1300" b="1" i="0" u="none">
+              <a:rPr sz="1550" b="1" i="0" u="none">
                 <a:solidFill>
                   <a:srgbClr val="FFFFFF"/>
                 </a:solidFill>
@@ -18190,7 +18190,7 @@
           <a:p>
             <a:pPr algn="l"/>
             <a:r>
-              <a:rPr sz="1100" b="0" i="0" u="none">
+              <a:rPr sz="1300" b="0" i="0" u="none">
                 <a:solidFill>
                   <a:srgbClr val="243044"/>
                 </a:solidFill>
@@ -18295,7 +18295,7 @@
           <a:p>
             <a:pPr algn="l"/>
             <a:r>
-              <a:rPr sz="1700" b="1" i="0" u="none">
+              <a:rPr sz="2000" b="1" i="0" u="none">
                 <a:solidFill>
                   <a:srgbClr val="1B2A41"/>
                 </a:solidFill>
@@ -18330,7 +18330,7 @@
           <a:p>
             <a:pPr algn="l"/>
             <a:r>
-              <a:rPr sz="1050" b="0" i="1" u="none">
+              <a:rPr sz="1250" b="0" i="1" u="none">
                 <a:solidFill>
                   <a:srgbClr val="1F497D"/>
                 </a:solidFill>
@@ -18394,7 +18394,7 @@
           <a:p>
             <a:pPr algn="l"/>
             <a:r>
-              <a:rPr sz="1050" b="1" i="0" u="none">
+              <a:rPr sz="1250" b="1" i="0" u="none">
                 <a:solidFill>
                   <a:srgbClr val="5B6778"/>
                 </a:solidFill>
@@ -18458,7 +18458,7 @@
           <a:p>
             <a:pPr algn="l"/>
             <a:r>
-              <a:rPr sz="1050" b="1" i="0" u="none">
+              <a:rPr sz="1250" b="1" i="0" u="none">
                 <a:solidFill>
                   <a:srgbClr val="16A34A"/>
                 </a:solidFill>
@@ -18541,7 +18541,7 @@
           <a:p>
             <a:pPr algn="l"/>
             <a:r>
-              <a:rPr sz="1500" b="1" i="0" u="none">
+              <a:rPr sz="1750" b="1" i="0" u="none">
                 <a:solidFill>
                   <a:srgbClr val="1B2A41"/>
                 </a:solidFill>
@@ -18576,7 +18576,7 @@
           <a:p>
             <a:pPr algn="l"/>
             <a:r>
-              <a:rPr sz="1200" b="0" i="1" u="none">
+              <a:rPr sz="1400" b="0" i="1" u="none">
                 <a:solidFill>
                   <a:srgbClr val="0B7468"/>
                 </a:solidFill>
@@ -18620,7 +18620,7 @@
               <a:buChar char="•"/>
             </a:pPr>
             <a:r>
-              <a:rPr sz="1050" b="0" i="0" u="none">
+              <a:rPr sz="1250" b="0" i="0" u="none">
                 <a:solidFill>
                   <a:srgbClr val="243044"/>
                 </a:solidFill>
@@ -18641,7 +18641,7 @@
               <a:buChar char="•"/>
             </a:pPr>
             <a:r>
-              <a:rPr sz="1050" b="0" i="0" u="none">
+              <a:rPr sz="1250" b="0" i="0" u="none">
                 <a:solidFill>
                   <a:srgbClr val="243044"/>
                 </a:solidFill>
@@ -18662,7 +18662,7 @@
               <a:buChar char="•"/>
             </a:pPr>
             <a:r>
-              <a:rPr sz="1050" b="0" i="0" u="none">
+              <a:rPr sz="1250" b="0" i="0" u="none">
                 <a:solidFill>
                   <a:srgbClr val="243044"/>
                 </a:solidFill>
@@ -18683,7 +18683,7 @@
               <a:buChar char="•"/>
             </a:pPr>
             <a:r>
-              <a:rPr sz="1050" b="0" i="0" u="none">
+              <a:rPr sz="1250" b="0" i="0" u="none">
                 <a:solidFill>
                   <a:srgbClr val="243044"/>
                 </a:solidFill>
@@ -18790,7 +18790,7 @@
           <a:p>
             <a:pPr algn="l"/>
             <a:r>
-              <a:rPr sz="1100" b="1" i="0" u="none">
+              <a:rPr sz="1300" b="1" i="0" u="none">
                 <a:solidFill>
                   <a:srgbClr val="1B2A41"/>
                 </a:solidFill>
@@ -18825,7 +18825,7 @@
           <a:p>
             <a:pPr algn="l"/>
             <a:r>
-              <a:rPr sz="950" b="0" i="0" u="sng">
+              <a:rPr sz="1100" b="0" i="0" u="sng">
                 <a:solidFill>
                   <a:srgbClr val="1155CC"/>
                 </a:solidFill>
@@ -18861,7 +18861,7 @@
           <a:p>
             <a:pPr algn="l"/>
             <a:r>
-              <a:rPr sz="900" b="0" i="1" u="none">
+              <a:rPr sz="1050" b="0" i="1" u="none">
                 <a:solidFill>
                   <a:srgbClr val="5B6778"/>
                 </a:solidFill>
@@ -19540,7 +19540,7 @@
           <a:p>
             <a:pPr algn="l"/>
             <a:r>
-              <a:rPr sz="1700" b="1" i="0" u="none">
+              <a:rPr sz="2000" b="1" i="0" u="none">
                 <a:solidFill>
                   <a:srgbClr val="1B2A41"/>
                 </a:solidFill>
@@ -19575,7 +19575,7 @@
           <a:p>
             <a:pPr algn="l"/>
             <a:r>
-              <a:rPr sz="1050" b="0" i="1" u="none">
+              <a:rPr sz="1250" b="0" i="1" u="none">
                 <a:solidFill>
                   <a:srgbClr val="1F497D"/>
                 </a:solidFill>
@@ -19748,7 +19748,7 @@
           <a:p>
             <a:pPr algn="l"/>
             <a:r>
-              <a:rPr sz="2600" b="1" i="0" u="none">
+              <a:rPr sz="3050" b="1" i="0" u="none">
                 <a:solidFill>
                   <a:srgbClr val="FFFFFF"/>
                 </a:solidFill>
@@ -19807,7 +19807,7 @@
           <a:p>
             <a:pPr algn="l"/>
             <a:r>
-              <a:rPr sz="1500" b="1" i="0" u="none">
+              <a:rPr sz="1750" b="1" i="0" u="none">
                 <a:solidFill>
                   <a:srgbClr val="1B2A41"/>
                 </a:solidFill>
@@ -19846,7 +19846,7 @@
               </a:lnSpc>
             </a:pPr>
             <a:r>
-              <a:rPr sz="1400" b="0" i="0" u="none">
+              <a:rPr sz="1650" b="0" i="0" u="none">
                 <a:solidFill>
                   <a:srgbClr val="243044"/>
                 </a:solidFill>
@@ -20055,7 +20055,7 @@
           <a:p>
             <a:pPr algn="l"/>
             <a:r>
-              <a:rPr sz="2600" b="1" i="0" u="none">
+              <a:rPr sz="3050" b="1" i="0" u="none">
                 <a:solidFill>
                   <a:srgbClr val="FFFFFF"/>
                 </a:solidFill>
@@ -20114,7 +20114,7 @@
           <a:p>
             <a:pPr algn="l"/>
             <a:r>
-              <a:rPr sz="1500" b="1" i="0" u="none">
+              <a:rPr sz="1750" b="1" i="0" u="none">
                 <a:solidFill>
                   <a:srgbClr val="1B2A41"/>
                 </a:solidFill>
@@ -20153,7 +20153,7 @@
               </a:lnSpc>
             </a:pPr>
             <a:r>
-              <a:rPr sz="1400" b="0" i="0" u="none">
+              <a:rPr sz="1650" b="0" i="0" u="none">
                 <a:solidFill>
                   <a:srgbClr val="243044"/>
                 </a:solidFill>
@@ -20362,7 +20362,7 @@
           <a:p>
             <a:pPr algn="l"/>
             <a:r>
-              <a:rPr sz="2600" b="1" i="0" u="none">
+              <a:rPr sz="3050" b="1" i="0" u="none">
                 <a:solidFill>
                   <a:srgbClr val="FFFFFF"/>
                 </a:solidFill>
@@ -20421,7 +20421,7 @@
           <a:p>
             <a:pPr algn="l"/>
             <a:r>
-              <a:rPr sz="1500" b="1" i="0" u="none">
+              <a:rPr sz="1750" b="1" i="0" u="none">
                 <a:solidFill>
                   <a:srgbClr val="1B2A41"/>
                 </a:solidFill>
@@ -20460,7 +20460,7 @@
               </a:lnSpc>
             </a:pPr>
             <a:r>
-              <a:rPr sz="1400" b="0" i="0" u="none">
+              <a:rPr sz="1650" b="0" i="0" u="none">
                 <a:solidFill>
                   <a:srgbClr val="243044"/>
                 </a:solidFill>
@@ -20669,7 +20669,7 @@
           <a:p>
             <a:pPr algn="l"/>
             <a:r>
-              <a:rPr sz="2600" b="1" i="0" u="none">
+              <a:rPr sz="3050" b="1" i="0" u="none">
                 <a:solidFill>
                   <a:srgbClr val="FFFFFF"/>
                 </a:solidFill>
@@ -20728,7 +20728,7 @@
           <a:p>
             <a:pPr algn="l"/>
             <a:r>
-              <a:rPr sz="1500" b="1" i="0" u="none">
+              <a:rPr sz="1750" b="1" i="0" u="none">
                 <a:solidFill>
                   <a:srgbClr val="1B2A41"/>
                 </a:solidFill>
@@ -20767,7 +20767,7 @@
               </a:lnSpc>
             </a:pPr>
             <a:r>
-              <a:rPr sz="1400" b="0" i="0" u="none">
+              <a:rPr sz="1650" b="0" i="0" u="none">
                 <a:solidFill>
                   <a:srgbClr val="243044"/>
                 </a:solidFill>
@@ -20976,7 +20976,7 @@
           <a:p>
             <a:pPr algn="l"/>
             <a:r>
-              <a:rPr sz="2600" b="1" i="0" u="none">
+              <a:rPr sz="3050" b="1" i="0" u="none">
                 <a:solidFill>
                   <a:srgbClr val="FFFFFF"/>
                 </a:solidFill>
@@ -21035,7 +21035,7 @@
           <a:p>
             <a:pPr algn="l"/>
             <a:r>
-              <a:rPr sz="1500" b="1" i="0" u="none">
+              <a:rPr sz="1750" b="1" i="0" u="none">
                 <a:solidFill>
                   <a:srgbClr val="1B2A41"/>
                 </a:solidFill>
@@ -21074,7 +21074,7 @@
               </a:lnSpc>
             </a:pPr>
             <a:r>
-              <a:rPr sz="1400" b="0" i="0" u="none">
+              <a:rPr sz="1650" b="0" i="0" u="none">
                 <a:solidFill>
                   <a:srgbClr val="243044"/>
                 </a:solidFill>
@@ -21283,7 +21283,7 @@
           <a:p>
             <a:pPr algn="l"/>
             <a:r>
-              <a:rPr sz="2600" b="1" i="0" u="none">
+              <a:rPr sz="3050" b="1" i="0" u="none">
                 <a:solidFill>
                   <a:srgbClr val="FFFFFF"/>
                 </a:solidFill>
@@ -21342,7 +21342,7 @@
           <a:p>
             <a:pPr algn="l"/>
             <a:r>
-              <a:rPr sz="1500" b="1" i="0" u="none">
+              <a:rPr sz="1750" b="1" i="0" u="none">
                 <a:solidFill>
                   <a:srgbClr val="1B2A41"/>
                 </a:solidFill>
@@ -21381,7 +21381,7 @@
               </a:lnSpc>
             </a:pPr>
             <a:r>
-              <a:rPr sz="1400" b="0" i="0" u="none">
+              <a:rPr sz="1650" b="0" i="0" u="none">
                 <a:solidFill>
                   <a:srgbClr val="243044"/>
                 </a:solidFill>
@@ -21486,7 +21486,7 @@
           <a:p>
             <a:pPr algn="l"/>
             <a:r>
-              <a:rPr sz="1700" b="1" i="0" u="none">
+              <a:rPr sz="2000" b="1" i="0" u="none">
                 <a:solidFill>
                   <a:srgbClr val="1B2A41"/>
                 </a:solidFill>
@@ -21521,7 +21521,7 @@
           <a:p>
             <a:pPr algn="l"/>
             <a:r>
-              <a:rPr sz="1050" b="0" i="1" u="none">
+              <a:rPr sz="1250" b="0" i="1" u="none">
                 <a:solidFill>
                   <a:srgbClr val="1F497D"/>
                 </a:solidFill>
@@ -21604,7 +21604,7 @@
           <a:p>
             <a:pPr algn="l"/>
             <a:r>
-              <a:rPr sz="1500" b="1" i="0" u="none">
+              <a:rPr sz="1750" b="1" i="0" u="none">
                 <a:solidFill>
                   <a:srgbClr val="16A34A"/>
                 </a:solidFill>
@@ -21648,7 +21648,7 @@
               <a:buChar char="•"/>
             </a:pPr>
             <a:r>
-              <a:rPr sz="1350" b="0" i="0" u="none">
+              <a:rPr sz="1600" b="0" i="0" u="none">
                 <a:solidFill>
                   <a:srgbClr val="243044"/>
                 </a:solidFill>
@@ -21669,7 +21669,7 @@
               <a:buChar char="•"/>
             </a:pPr>
             <a:r>
-              <a:rPr sz="1350" b="0" i="0" u="none">
+              <a:rPr sz="1600" b="0" i="0" u="none">
                 <a:solidFill>
                   <a:srgbClr val="243044"/>
                 </a:solidFill>
@@ -21690,7 +21690,7 @@
               <a:buChar char="•"/>
             </a:pPr>
             <a:r>
-              <a:rPr sz="1350" b="0" i="0" u="none">
+              <a:rPr sz="1600" b="0" i="0" u="none">
                 <a:solidFill>
                   <a:srgbClr val="243044"/>
                 </a:solidFill>
@@ -21711,7 +21711,7 @@
               <a:buChar char="•"/>
             </a:pPr>
             <a:r>
-              <a:rPr sz="1350" b="0" i="0" u="none">
+              <a:rPr sz="1600" b="0" i="0" u="none">
                 <a:solidFill>
                   <a:srgbClr val="243044"/>
                 </a:solidFill>
@@ -21794,7 +21794,7 @@
           <a:p>
             <a:pPr algn="l"/>
             <a:r>
-              <a:rPr sz="1500" b="1" i="0" u="none">
+              <a:rPr sz="1750" b="1" i="0" u="none">
                 <a:solidFill>
                   <a:srgbClr val="D97706"/>
                 </a:solidFill>
@@ -21838,7 +21838,7 @@
               <a:buChar char="•"/>
             </a:pPr>
             <a:r>
-              <a:rPr sz="1350" b="0" i="0" u="none">
+              <a:rPr sz="1600" b="0" i="0" u="none">
                 <a:solidFill>
                   <a:srgbClr val="243044"/>
                 </a:solidFill>
@@ -21859,7 +21859,7 @@
               <a:buChar char="•"/>
             </a:pPr>
             <a:r>
-              <a:rPr sz="1350" b="0" i="0" u="none">
+              <a:rPr sz="1600" b="0" i="0" u="none">
                 <a:solidFill>
                   <a:srgbClr val="243044"/>
                 </a:solidFill>
@@ -21880,7 +21880,7 @@
               <a:buChar char="•"/>
             </a:pPr>
             <a:r>
-              <a:rPr sz="1350" b="0" i="0" u="none">
+              <a:rPr sz="1600" b="0" i="0" u="none">
                 <a:solidFill>
                   <a:srgbClr val="243044"/>
                 </a:solidFill>
@@ -21901,7 +21901,7 @@
               <a:buChar char="•"/>
             </a:pPr>
             <a:r>
-              <a:rPr sz="1350" b="0" i="0" u="none">
+              <a:rPr sz="1600" b="0" i="0" u="none">
                 <a:solidFill>
                   <a:srgbClr val="243044"/>
                 </a:solidFill>
@@ -21984,7 +21984,7 @@
           <a:p>
             <a:pPr algn="l"/>
             <a:r>
-              <a:rPr sz="1500" b="1" i="0" u="none">
+              <a:rPr sz="1750" b="1" i="0" u="none">
                 <a:solidFill>
                   <a:srgbClr val="2A6FB0"/>
                 </a:solidFill>
@@ -22028,7 +22028,7 @@
               <a:buChar char="•"/>
             </a:pPr>
             <a:r>
-              <a:rPr sz="1350" b="0" i="0" u="none">
+              <a:rPr sz="1600" b="0" i="0" u="none">
                 <a:solidFill>
                   <a:srgbClr val="243044"/>
                 </a:solidFill>
@@ -22049,7 +22049,7 @@
               <a:buChar char="•"/>
             </a:pPr>
             <a:r>
-              <a:rPr sz="1350" b="0" i="0" u="none">
+              <a:rPr sz="1600" b="0" i="0" u="none">
                 <a:solidFill>
                   <a:srgbClr val="243044"/>
                 </a:solidFill>
@@ -22070,7 +22070,7 @@
               <a:buChar char="•"/>
             </a:pPr>
             <a:r>
-              <a:rPr sz="1350" b="0" i="0" u="none">
+              <a:rPr sz="1600" b="0" i="0" u="none">
                 <a:solidFill>
                   <a:srgbClr val="243044"/>
                 </a:solidFill>
@@ -22091,7 +22091,7 @@
               <a:buChar char="•"/>
             </a:pPr>
             <a:r>
-              <a:rPr sz="1350" b="0" i="0" u="none">
+              <a:rPr sz="1600" b="0" i="0" u="none">
                 <a:solidFill>
                   <a:srgbClr val="243044"/>
                 </a:solidFill>
@@ -22731,7 +22731,7 @@
           <a:p>
             <a:pPr algn="l"/>
             <a:r>
-              <a:rPr sz="1700" b="1" i="0" u="none">
+              <a:rPr sz="2000" b="1" i="0" u="none">
                 <a:solidFill>
                   <a:srgbClr val="1B2A41"/>
                 </a:solidFill>
@@ -22766,7 +22766,7 @@
           <a:p>
             <a:pPr algn="l"/>
             <a:r>
-              <a:rPr sz="1050" b="0" i="1" u="none">
+              <a:rPr sz="1250" b="0" i="1" u="none">
                 <a:solidFill>
                   <a:srgbClr val="1F497D"/>
                 </a:solidFill>
@@ -22853,7 +22853,7 @@
               </a:spcAft>
             </a:pPr>
             <a:r>
-              <a:rPr sz="1300" b="1" i="0" u="none">
+              <a:rPr sz="1550" b="1" i="0" u="none">
                 <a:solidFill>
                   <a:srgbClr val="0B7468"/>
                 </a:solidFill>
@@ -22862,7 +22862,7 @@
               <a:t>Technology: </a:t>
             </a:r>
             <a:r>
-              <a:rPr sz="1300" b="0" i="0" u="none">
+              <a:rPr sz="1550" b="0" i="0" u="none">
                 <a:solidFill>
                   <a:srgbClr val="243044"/>
                 </a:solidFill>
@@ -22878,7 +22878,7 @@
               </a:spcAft>
             </a:pPr>
             <a:r>
-              <a:rPr sz="1300" b="1" i="0" u="none">
+              <a:rPr sz="1550" b="1" i="0" u="none">
                 <a:solidFill>
                   <a:srgbClr val="0B7468"/>
                 </a:solidFill>
@@ -22887,7 +22887,7 @@
               <a:t>Implementation: </a:t>
             </a:r>
             <a:r>
-              <a:rPr sz="1300" b="0" i="0" u="none">
+              <a:rPr sz="1550" b="0" i="0" u="none">
                 <a:solidFill>
                   <a:srgbClr val="243044"/>
                 </a:solidFill>
@@ -22903,7 +22903,7 @@
               </a:spcAft>
             </a:pPr>
             <a:r>
-              <a:rPr sz="1300" b="1" i="0" u="none">
+              <a:rPr sz="1550" b="1" i="0" u="none">
                 <a:solidFill>
                   <a:srgbClr val="0B7468"/>
                 </a:solidFill>
@@ -22912,7 +22912,7 @@
               <a:t>Integration: </a:t>
             </a:r>
             <a:r>
-              <a:rPr sz="1300" b="0" i="0" u="none">
+              <a:rPr sz="1550" b="0" i="0" u="none">
                 <a:solidFill>
                   <a:srgbClr val="243044"/>
                 </a:solidFill>
@@ -22928,7 +22928,7 @@
               </a:spcAft>
             </a:pPr>
             <a:r>
-              <a:rPr sz="1300" b="1" i="0" u="none">
+              <a:rPr sz="1550" b="1" i="0" u="none">
                 <a:solidFill>
                   <a:srgbClr val="0B7468"/>
                 </a:solidFill>
@@ -22937,7 +22937,7 @@
               <a:t>Validation: </a:t>
             </a:r>
             <a:r>
-              <a:rPr sz="1300" b="0" i="0" u="none">
+              <a:rPr sz="1550" b="0" i="0" u="none">
                 <a:solidFill>
                   <a:srgbClr val="243044"/>
                 </a:solidFill>
@@ -23042,7 +23042,7 @@
           <a:p>
             <a:pPr algn="l"/>
             <a:r>
-              <a:rPr sz="1700" b="1" i="0" u="none">
+              <a:rPr sz="2000" b="1" i="0" u="none">
                 <a:solidFill>
                   <a:srgbClr val="1B2A41"/>
                 </a:solidFill>
@@ -23077,7 +23077,7 @@
           <a:p>
             <a:pPr algn="l"/>
             <a:r>
-              <a:rPr sz="1050" b="0" i="1" u="none">
+              <a:rPr sz="1250" b="0" i="1" u="none">
                 <a:solidFill>
                   <a:srgbClr val="1F497D"/>
                 </a:solidFill>
@@ -23160,7 +23160,7 @@
           <a:p>
             <a:pPr algn="l"/>
             <a:r>
-              <a:rPr sz="1100" b="1" i="0" u="none">
+              <a:rPr sz="1300" b="1" i="0" u="none">
                 <a:solidFill>
                   <a:srgbClr val="9B1C1C"/>
                 </a:solidFill>
@@ -23279,7 +23279,7 @@
           <a:p>
             <a:pPr algn="l"/>
             <a:r>
-              <a:rPr sz="1050" b="0" i="0" u="none">
+              <a:rPr sz="1250" b="0" i="0" u="none">
                 <a:solidFill>
                   <a:srgbClr val="243044"/>
                 </a:solidFill>
@@ -23362,7 +23362,7 @@
           <a:p>
             <a:pPr algn="l"/>
             <a:r>
-              <a:rPr sz="1100" b="1" i="0" u="none">
+              <a:rPr sz="1300" b="1" i="0" u="none">
                 <a:solidFill>
                   <a:srgbClr val="9B1C1C"/>
                 </a:solidFill>
@@ -23481,7 +23481,7 @@
           <a:p>
             <a:pPr algn="l"/>
             <a:r>
-              <a:rPr sz="1050" b="0" i="0" u="none">
+              <a:rPr sz="1250" b="0" i="0" u="none">
                 <a:solidFill>
                   <a:srgbClr val="243044"/>
                 </a:solidFill>
@@ -23564,7 +23564,7 @@
           <a:p>
             <a:pPr algn="l"/>
             <a:r>
-              <a:rPr sz="1100" b="1" i="0" u="none">
+              <a:rPr sz="1300" b="1" i="0" u="none">
                 <a:solidFill>
                   <a:srgbClr val="9B1C1C"/>
                 </a:solidFill>
@@ -23683,7 +23683,7 @@
           <a:p>
             <a:pPr algn="l"/>
             <a:r>
-              <a:rPr sz="1050" b="0" i="0" u="none">
+              <a:rPr sz="1250" b="0" i="0" u="none">
                 <a:solidFill>
                   <a:srgbClr val="243044"/>
                 </a:solidFill>
@@ -23766,7 +23766,7 @@
           <a:p>
             <a:pPr algn="l"/>
             <a:r>
-              <a:rPr sz="1100" b="1" i="0" u="none">
+              <a:rPr sz="1300" b="1" i="0" u="none">
                 <a:solidFill>
                   <a:srgbClr val="9B1C1C"/>
                 </a:solidFill>
@@ -23885,7 +23885,7 @@
           <a:p>
             <a:pPr algn="l"/>
             <a:r>
-              <a:rPr sz="1050" b="0" i="0" u="none">
+              <a:rPr sz="1250" b="0" i="0" u="none">
                 <a:solidFill>
                   <a:srgbClr val="243044"/>
                 </a:solidFill>
@@ -23990,7 +23990,7 @@
           <a:p>
             <a:pPr algn="l"/>
             <a:r>
-              <a:rPr sz="1700" b="1" i="0" u="none">
+              <a:rPr sz="2000" b="1" i="0" u="none">
                 <a:solidFill>
                   <a:srgbClr val="1B2A41"/>
                 </a:solidFill>
@@ -24077,7 +24077,7 @@
               </a:spcAft>
             </a:pPr>
             <a:r>
-              <a:rPr sz="1200" b="1" i="0" u="none">
+              <a:rPr sz="1400" b="1" i="0" u="none">
                 <a:solidFill>
                   <a:srgbClr val="0B7468"/>
                 </a:solidFill>
@@ -24086,7 +24086,7 @@
               <a:t>Data Foundation: </a:t>
             </a:r>
             <a:r>
-              <a:rPr sz="1200" b="0" i="0" u="none">
+              <a:rPr sz="1400" b="0" i="0" u="none">
                 <a:solidFill>
                   <a:srgbClr val="243044"/>
                 </a:solidFill>
@@ -24102,7 +24102,7 @@
               </a:spcAft>
             </a:pPr>
             <a:r>
-              <a:rPr sz="1200" b="1" i="0" u="none">
+              <a:rPr sz="1400" b="1" i="0" u="none">
                 <a:solidFill>
                   <a:srgbClr val="0B7468"/>
                 </a:solidFill>
@@ -24111,7 +24111,7 @@
               <a:t>Operational Value: </a:t>
             </a:r>
             <a:r>
-              <a:rPr sz="1200" b="0" i="0" u="none">
+              <a:rPr sz="1400" b="0" i="0" u="none">
                 <a:solidFill>
                   <a:srgbClr val="243044"/>
                 </a:solidFill>
@@ -24127,7 +24127,7 @@
               </a:spcAft>
             </a:pPr>
             <a:r>
-              <a:rPr sz="1200" b="1" i="0" u="none">
+              <a:rPr sz="1400" b="1" i="0" u="none">
                 <a:solidFill>
                   <a:srgbClr val="0B7468"/>
                 </a:solidFill>
@@ -24136,7 +24136,7 @@
               <a:t>Scalability: </a:t>
             </a:r>
             <a:r>
-              <a:rPr sz="1200" b="0" i="0" u="none">
+              <a:rPr sz="1400" b="0" i="0" u="none">
                 <a:solidFill>
                   <a:srgbClr val="243044"/>
                 </a:solidFill>
@@ -24219,7 +24219,7 @@
           <a:p>
             <a:pPr algn="l"/>
             <a:r>
-              <a:rPr sz="1050" b="1" i="0" u="none">
+              <a:rPr sz="1250" b="1" i="0" u="none">
                 <a:solidFill>
                   <a:srgbClr val="2A6FB0"/>
                 </a:solidFill>
@@ -24254,7 +24254,7 @@
           <a:p>
             <a:pPr algn="l"/>
             <a:r>
-              <a:rPr sz="2000" b="1" i="0" u="none">
+              <a:rPr sz="2350" b="1" i="0" u="none">
                 <a:solidFill>
                   <a:srgbClr val="1B2A41"/>
                 </a:solidFill>
@@ -24263,7 +24263,7 @@
               <a:t>4,61,312</a:t>
             </a:r>
             <a:r>
-              <a:rPr sz="1100" b="0" i="0" u="none">
+              <a:rPr sz="1300" b="0" i="0" u="none">
                 <a:solidFill>
                   <a:srgbClr val="243044"/>
                 </a:solidFill>
@@ -24272,7 +24272,7 @@
               <a:t>  road accidents   </a:t>
             </a:r>
             <a:r>
-              <a:rPr sz="2000" b="1" i="0" u="none">
+              <a:rPr sz="2350" b="1" i="0" u="none">
                 <a:solidFill>
                   <a:srgbClr val="DC2626"/>
                 </a:solidFill>
@@ -24281,7 +24281,7 @@
               <a:t>1,68,491</a:t>
             </a:r>
             <a:r>
-              <a:rPr sz="1100" b="0" i="0" u="none">
+              <a:rPr sz="1300" b="0" i="0" u="none">
                 <a:solidFill>
                   <a:srgbClr val="243044"/>
                 </a:solidFill>
@@ -24316,7 +24316,7 @@
           <a:p>
             <a:pPr algn="l"/>
             <a:r>
-              <a:rPr sz="900" b="0" i="1" u="none">
+              <a:rPr sz="1050" b="0" i="1" u="none">
                 <a:solidFill>
                   <a:srgbClr val="5B6778"/>
                 </a:solidFill>
@@ -24421,7 +24421,7 @@
           <a:p>
             <a:pPr algn="l"/>
             <a:r>
-              <a:rPr sz="1700" b="1" i="0" u="none">
+              <a:rPr sz="2000" b="1" i="0" u="none">
                 <a:solidFill>
                   <a:srgbClr val="1B2A41"/>
                 </a:solidFill>
@@ -24456,7 +24456,7 @@
           <a:p>
             <a:pPr algn="l"/>
             <a:r>
-              <a:rPr sz="1050" b="0" i="1" u="none">
+              <a:rPr sz="1250" b="0" i="1" u="none">
                 <a:solidFill>
                   <a:srgbClr val="1F497D"/>
                 </a:solidFill>
@@ -24537,7 +24537,7 @@
           <a:p>
             <a:pPr algn="l"/>
             <a:r>
-              <a:rPr sz="1800" b="1" i="0" u="none">
+              <a:rPr sz="2100" b="1" i="0" u="none">
                 <a:solidFill>
                   <a:srgbClr val="FFFFFF"/>
                 </a:solidFill>
@@ -24576,7 +24576,7 @@
               </a:lnSpc>
             </a:pPr>
             <a:r>
-              <a:rPr sz="1300" b="0" i="0" u="none">
+              <a:rPr sz="1550" b="0" i="0" u="none">
                 <a:solidFill>
                   <a:srgbClr val="FFFFFF"/>
                 </a:solidFill>
@@ -24657,7 +24657,7 @@
           <a:p>
             <a:pPr algn="l"/>
             <a:r>
-              <a:rPr sz="1800" b="1" i="0" u="none">
+              <a:rPr sz="2100" b="1" i="0" u="none">
                 <a:solidFill>
                   <a:srgbClr val="FFFFFF"/>
                 </a:solidFill>
@@ -24696,7 +24696,7 @@
               </a:lnSpc>
             </a:pPr>
             <a:r>
-              <a:rPr sz="1300" b="0" i="0" u="none">
+              <a:rPr sz="1550" b="0" i="0" u="none">
                 <a:solidFill>
                   <a:srgbClr val="FFFFFF"/>
                 </a:solidFill>
@@ -24777,7 +24777,7 @@
           <a:p>
             <a:pPr algn="l"/>
             <a:r>
-              <a:rPr sz="1800" b="1" i="0" u="none">
+              <a:rPr sz="2100" b="1" i="0" u="none">
                 <a:solidFill>
                   <a:srgbClr val="FFFFFF"/>
                 </a:solidFill>
@@ -24816,7 +24816,7 @@
               </a:lnSpc>
             </a:pPr>
             <a:r>
-              <a:rPr sz="1300" b="0" i="0" u="none">
+              <a:rPr sz="1550" b="0" i="0" u="none">
                 <a:solidFill>
                   <a:srgbClr val="FFFFFF"/>
                 </a:solidFill>
@@ -24921,7 +24921,7 @@
           <a:p>
             <a:pPr algn="l"/>
             <a:r>
-              <a:rPr sz="1700" b="1" i="0" u="none">
+              <a:rPr sz="2000" b="1" i="0" u="none">
                 <a:solidFill>
                   <a:srgbClr val="1B2A41"/>
                 </a:solidFill>
@@ -24956,7 +24956,7 @@
           <a:p>
             <a:pPr algn="l"/>
             <a:r>
-              <a:rPr sz="1050" b="0" i="1" u="none">
+              <a:rPr sz="1250" b="0" i="1" u="none">
                 <a:solidFill>
                   <a:srgbClr val="1F497D"/>
                 </a:solidFill>
@@ -25109,7 +25109,7 @@
           <a:p>
             <a:pPr algn="l"/>
             <a:r>
-              <a:rPr sz="1000" b="1" i="0" u="none">
+              <a:rPr sz="1200" b="1" i="0" u="none">
                 <a:solidFill>
                   <a:srgbClr val="1B2A41"/>
                 </a:solidFill>
@@ -25262,7 +25262,7 @@
           <a:p>
             <a:pPr algn="l"/>
             <a:r>
-              <a:rPr sz="1000" b="1" i="0" u="none">
+              <a:rPr sz="1200" b="1" i="0" u="none">
                 <a:solidFill>
                   <a:srgbClr val="1B2A41"/>
                 </a:solidFill>
@@ -25415,7 +25415,7 @@
           <a:p>
             <a:pPr algn="l"/>
             <a:r>
-              <a:rPr sz="1000" b="1" i="0" u="none">
+              <a:rPr sz="1200" b="1" i="0" u="none">
                 <a:solidFill>
                   <a:srgbClr val="1B2A41"/>
                 </a:solidFill>
@@ -25568,7 +25568,7 @@
           <a:p>
             <a:pPr algn="l"/>
             <a:r>
-              <a:rPr sz="1000" b="1" i="0" u="none">
+              <a:rPr sz="1200" b="1" i="0" u="none">
                 <a:solidFill>
                   <a:srgbClr val="1B2A41"/>
                 </a:solidFill>
@@ -25721,7 +25721,7 @@
           <a:p>
             <a:pPr algn="l"/>
             <a:r>
-              <a:rPr sz="1000" b="1" i="0" u="none">
+              <a:rPr sz="1200" b="1" i="0" u="none">
                 <a:solidFill>
                   <a:srgbClr val="1B2A41"/>
                 </a:solidFill>
@@ -25874,7 +25874,7 @@
           <a:p>
             <a:pPr algn="l"/>
             <a:r>
-              <a:rPr sz="1000" b="1" i="0" u="none">
+              <a:rPr sz="1200" b="1" i="0" u="none">
                 <a:solidFill>
                   <a:srgbClr val="1B2A41"/>
                 </a:solidFill>
@@ -26514,7 +26514,7 @@
           <a:p>
             <a:pPr algn="l"/>
             <a:r>
-              <a:rPr sz="1700" b="1" i="0" u="none">
+              <a:rPr sz="2000" b="1" i="0" u="none">
                 <a:solidFill>
                   <a:srgbClr val="1B2A41"/>
                 </a:solidFill>
@@ -26549,7 +26549,7 @@
           <a:p>
             <a:pPr algn="l"/>
             <a:r>
-              <a:rPr sz="1050" b="0" i="1" u="none">
+              <a:rPr sz="1250" b="0" i="1" u="none">
                 <a:solidFill>
                   <a:srgbClr val="1F497D"/>
                 </a:solidFill>
@@ -26702,7 +26702,7 @@
           <a:p>
             <a:pPr algn="l"/>
             <a:r>
-              <a:rPr sz="1600" b="1" i="0" u="none">
+              <a:rPr sz="1900" b="1" i="0" u="none">
                 <a:solidFill>
                   <a:srgbClr val="1B2A41"/>
                 </a:solidFill>
@@ -26737,7 +26737,7 @@
           <a:p>
             <a:pPr algn="l"/>
             <a:r>
-              <a:rPr sz="1350" b="0" i="0" u="none">
+              <a:rPr sz="1600" b="0" i="0" u="none">
                 <a:solidFill>
                   <a:srgbClr val="243044"/>
                 </a:solidFill>
@@ -26914,7 +26914,7 @@
           <a:p>
             <a:pPr algn="l"/>
             <a:r>
-              <a:rPr sz="1600" b="1" i="0" u="none">
+              <a:rPr sz="1900" b="1" i="0" u="none">
                 <a:solidFill>
                   <a:srgbClr val="1B2A41"/>
                 </a:solidFill>
@@ -26949,7 +26949,7 @@
           <a:p>
             <a:pPr algn="l"/>
             <a:r>
-              <a:rPr sz="1350" b="0" i="0" u="none">
+              <a:rPr sz="1600" b="0" i="0" u="none">
                 <a:solidFill>
                   <a:srgbClr val="243044"/>
                 </a:solidFill>
@@ -27126,7 +27126,7 @@
           <a:p>
             <a:pPr algn="l"/>
             <a:r>
-              <a:rPr sz="1600" b="1" i="0" u="none">
+              <a:rPr sz="1900" b="1" i="0" u="none">
                 <a:solidFill>
                   <a:srgbClr val="1B2A41"/>
                 </a:solidFill>
@@ -27161,7 +27161,7 @@
           <a:p>
             <a:pPr algn="l"/>
             <a:r>
-              <a:rPr sz="1350" b="0" i="0" u="none">
+              <a:rPr sz="1600" b="0" i="0" u="none">
                 <a:solidFill>
                   <a:srgbClr val="243044"/>
                 </a:solidFill>
@@ -27338,7 +27338,7 @@
           <a:p>
             <a:pPr algn="l"/>
             <a:r>
-              <a:rPr sz="1600" b="1" i="0" u="none">
+              <a:rPr sz="1900" b="1" i="0" u="none">
                 <a:solidFill>
                   <a:srgbClr val="1B2A41"/>
                 </a:solidFill>
@@ -27373,7 +27373,7 @@
           <a:p>
             <a:pPr algn="l"/>
             <a:r>
-              <a:rPr sz="1350" b="0" i="0" u="none">
+              <a:rPr sz="1600" b="0" i="0" u="none">
                 <a:solidFill>
                   <a:srgbClr val="243044"/>
                 </a:solidFill>
@@ -27550,7 +27550,7 @@
           <a:p>
             <a:pPr algn="l"/>
             <a:r>
-              <a:rPr sz="1600" b="1" i="0" u="none">
+              <a:rPr sz="1900" b="1" i="0" u="none">
                 <a:solidFill>
                   <a:srgbClr val="1B2A41"/>
                 </a:solidFill>
@@ -27585,7 +27585,7 @@
           <a:p>
             <a:pPr algn="l"/>
             <a:r>
-              <a:rPr sz="1350" b="0" i="0" u="none">
+              <a:rPr sz="1600" b="0" i="0" u="none">
                 <a:solidFill>
                   <a:srgbClr val="243044"/>
                 </a:solidFill>
@@ -27644,7 +27644,7 @@
           <a:p>
             <a:pPr algn="r"/>
             <a:r>
-              <a:rPr sz="750" b="0" i="1" u="none">
+              <a:rPr sz="900" b="0" i="1" u="none">
                 <a:solidFill>
                   <a:srgbClr val="5B6778"/>
                 </a:solidFill>
@@ -27749,7 +27749,7 @@
           <a:p>
             <a:pPr algn="l"/>
             <a:r>
-              <a:rPr sz="1700" b="1" i="0" u="none">
+              <a:rPr sz="2000" b="1" i="0" u="none">
                 <a:solidFill>
                   <a:srgbClr val="1B2A41"/>
                 </a:solidFill>
@@ -27784,7 +27784,7 @@
           <a:p>
             <a:pPr algn="l"/>
             <a:r>
-              <a:rPr sz="1050" b="0" i="1" u="none">
+              <a:rPr sz="1250" b="0" i="1" u="none">
                 <a:solidFill>
                   <a:srgbClr val="1F497D"/>
                 </a:solidFill>
@@ -27937,7 +27937,7 @@
           <a:p>
             <a:pPr algn="l"/>
             <a:r>
-              <a:rPr sz="1300" b="1" i="0" u="none">
+              <a:rPr sz="1550" b="1" i="0" u="none">
                 <a:solidFill>
                   <a:srgbClr val="16A34A"/>
                 </a:solidFill>
@@ -27972,7 +27972,7 @@
           <a:p>
             <a:pPr algn="l"/>
             <a:r>
-              <a:rPr sz="1400" b="0" i="0" u="none">
+              <a:rPr sz="1650" b="0" i="0" u="none">
                 <a:solidFill>
                   <a:srgbClr val="243044"/>
                 </a:solidFill>
@@ -28125,7 +28125,7 @@
           <a:p>
             <a:pPr algn="l"/>
             <a:r>
-              <a:rPr sz="1300" b="1" i="0" u="none">
+              <a:rPr sz="1550" b="1" i="0" u="none">
                 <a:solidFill>
                   <a:srgbClr val="2A6FB0"/>
                 </a:solidFill>
@@ -28160,7 +28160,7 @@
           <a:p>
             <a:pPr algn="l"/>
             <a:r>
-              <a:rPr sz="1400" b="0" i="0" u="none">
+              <a:rPr sz="1650" b="0" i="0" u="none">
                 <a:solidFill>
                   <a:srgbClr val="243044"/>
                 </a:solidFill>
@@ -28313,7 +28313,7 @@
           <a:p>
             <a:pPr algn="l"/>
             <a:r>
-              <a:rPr sz="1300" b="1" i="0" u="none">
+              <a:rPr sz="1550" b="1" i="0" u="none">
                 <a:solidFill>
                   <a:srgbClr val="118F95"/>
                 </a:solidFill>
@@ -28348,7 +28348,7 @@
           <a:p>
             <a:pPr algn="l"/>
             <a:r>
-              <a:rPr sz="1400" b="0" i="0" u="none">
+              <a:rPr sz="1650" b="0" i="0" u="none">
                 <a:solidFill>
                   <a:srgbClr val="243044"/>
                 </a:solidFill>
@@ -28501,7 +28501,7 @@
           <a:p>
             <a:pPr algn="l"/>
             <a:r>
-              <a:rPr sz="1300" b="1" i="0" u="none">
+              <a:rPr sz="1550" b="1" i="0" u="none">
                 <a:solidFill>
                   <a:srgbClr val="0B7468"/>
                 </a:solidFill>
@@ -28536,7 +28536,7 @@
           <a:p>
             <a:pPr algn="l"/>
             <a:r>
-              <a:rPr sz="1400" b="0" i="0" u="none">
+              <a:rPr sz="1650" b="0" i="0" u="none">
                 <a:solidFill>
                   <a:srgbClr val="243044"/>
                 </a:solidFill>
@@ -28619,7 +28619,7 @@
           <a:p>
             <a:pPr algn="l"/>
             <a:r>
-              <a:rPr sz="1400" b="1" i="0" u="none">
+              <a:rPr sz="1650" b="1" i="0" u="none">
                 <a:solidFill>
                   <a:srgbClr val="0B7468"/>
                 </a:solidFill>
@@ -28658,7 +28658,7 @@
               </a:spcAft>
             </a:pPr>
             <a:r>
-              <a:rPr sz="1350" b="1" i="0" u="none">
+              <a:rPr sz="1600" b="1" i="0" u="none">
                 <a:solidFill>
                   <a:srgbClr val="1B2A41"/>
                 </a:solidFill>
@@ -28667,7 +28667,7 @@
               <a:t>Social: </a:t>
             </a:r>
             <a:r>
-              <a:rPr sz="1350" b="0" i="0" u="none">
+              <a:rPr sz="1600" b="0" i="0" u="none">
                 <a:solidFill>
                   <a:srgbClr val="243044"/>
                 </a:solidFill>
@@ -28683,7 +28683,7 @@
               </a:spcAft>
             </a:pPr>
             <a:r>
-              <a:rPr sz="1350" b="1" i="0" u="none">
+              <a:rPr sz="1600" b="1" i="0" u="none">
                 <a:solidFill>
                   <a:srgbClr val="1B2A41"/>
                 </a:solidFill>
@@ -28692,7 +28692,7 @@
               <a:t>Economic: </a:t>
             </a:r>
             <a:r>
-              <a:rPr sz="1350" b="0" i="0" u="none">
+              <a:rPr sz="1600" b="0" i="0" u="none">
                 <a:solidFill>
                   <a:srgbClr val="243044"/>
                 </a:solidFill>
@@ -28708,7 +28708,7 @@
               </a:spcAft>
             </a:pPr>
             <a:r>
-              <a:rPr sz="1350" b="1" i="0" u="none">
+              <a:rPr sz="1600" b="1" i="0" u="none">
                 <a:solidFill>
                   <a:srgbClr val="1B2A41"/>
                 </a:solidFill>
@@ -28717,7 +28717,7 @@
               <a:t>Environmental: </a:t>
             </a:r>
             <a:r>
-              <a:rPr sz="1350" b="0" i="0" u="none">
+              <a:rPr sz="1600" b="0" i="0" u="none">
                 <a:solidFill>
                   <a:srgbClr val="243044"/>
                 </a:solidFill>
@@ -29370,7 +29370,7 @@
           <a:p>
             <a:pPr algn="l"/>
             <a:r>
-              <a:rPr sz="2400" b="0" i="0" u="none">
+              <a:rPr sz="2850" b="0" i="0" u="none">
                 <a:solidFill>
                   <a:srgbClr val="111111"/>
                 </a:solidFill>
@@ -29449,7 +29449,7 @@
           <a:p>
             <a:pPr algn="l"/>
             <a:r>
-              <a:rPr sz="850" b="1" i="0" u="none">
+              <a:rPr sz="1000" b="1" i="0" u="none">
                 <a:solidFill>
                   <a:srgbClr val="111111"/>
                 </a:solidFill>
@@ -29484,7 +29484,7 @@
           <a:p>
             <a:pPr algn="l"/>
             <a:r>
-              <a:rPr sz="1100" b="0" i="0" u="none">
+              <a:rPr sz="1300" b="0" i="0" u="none">
                 <a:solidFill>
                   <a:srgbClr val="1B2A41"/>
                 </a:solidFill>
@@ -29563,7 +29563,7 @@
           <a:p>
             <a:pPr algn="l"/>
             <a:r>
-              <a:rPr sz="850" b="1" i="0" u="none">
+              <a:rPr sz="1000" b="1" i="0" u="none">
                 <a:solidFill>
                   <a:srgbClr val="111111"/>
                 </a:solidFill>
@@ -29598,7 +29598,7 @@
           <a:p>
             <a:pPr algn="l"/>
             <a:r>
-              <a:rPr sz="1100" b="0" i="0" u="none">
+              <a:rPr sz="1300" b="0" i="0" u="none">
                 <a:solidFill>
                   <a:srgbClr val="1B2A41"/>
                 </a:solidFill>
@@ -29677,7 +29677,7 @@
           <a:p>
             <a:pPr algn="l"/>
             <a:r>
-              <a:rPr sz="850" b="1" i="0" u="none">
+              <a:rPr sz="1000" b="1" i="0" u="none">
                 <a:solidFill>
                   <a:srgbClr val="111111"/>
                 </a:solidFill>
@@ -29712,7 +29712,7 @@
           <a:p>
             <a:pPr algn="l"/>
             <a:r>
-              <a:rPr sz="1100" b="0" i="0" u="none">
+              <a:rPr sz="1300" b="0" i="0" u="none">
                 <a:solidFill>
                   <a:srgbClr val="1B2A41"/>
                 </a:solidFill>
@@ -29791,7 +29791,7 @@
           <a:p>
             <a:pPr algn="l"/>
             <a:r>
-              <a:rPr sz="850" b="1" i="0" u="none">
+              <a:rPr sz="1000" b="1" i="0" u="none">
                 <a:solidFill>
                   <a:srgbClr val="111111"/>
                 </a:solidFill>
@@ -29826,7 +29826,7 @@
           <a:p>
             <a:pPr algn="l"/>
             <a:r>
-              <a:rPr sz="1100" b="0" i="0" u="none">
+              <a:rPr sz="1300" b="0" i="0" u="none">
                 <a:solidFill>
                   <a:srgbClr val="1B2A41"/>
                 </a:solidFill>
@@ -29907,7 +29907,7 @@
           <a:p>
             <a:pPr algn="l"/>
             <a:r>
-              <a:rPr sz="1400" b="1" i="0" u="none">
+              <a:rPr sz="1650" b="1" i="0" u="none">
                 <a:solidFill>
                   <a:srgbClr val="111111"/>
                 </a:solidFill>
@@ -29975,7 +29975,7 @@
               <a:buChar char="•"/>
             </a:pPr>
             <a:r>
-              <a:rPr sz="1250" b="0" i="0" u="none">
+              <a:rPr sz="1500" b="0" i="0" u="none">
                 <a:solidFill>
                   <a:srgbClr val="243044"/>
                 </a:solidFill>
@@ -29996,7 +29996,7 @@
               <a:buChar char="•"/>
             </a:pPr>
             <a:r>
-              <a:rPr sz="1250" b="0" i="0" u="none">
+              <a:rPr sz="1500" b="0" i="0" u="none">
                 <a:solidFill>
                   <a:srgbClr val="243044"/>
                 </a:solidFill>
@@ -30017,7 +30017,7 @@
               <a:buChar char="•"/>
             </a:pPr>
             <a:r>
-              <a:rPr sz="1250" b="0" i="0" u="none">
+              <a:rPr sz="1500" b="0" i="0" u="none">
                 <a:solidFill>
                   <a:srgbClr val="243044"/>
                 </a:solidFill>
@@ -30038,7 +30038,7 @@
               <a:buChar char="•"/>
             </a:pPr>
             <a:r>
-              <a:rPr sz="1250" b="0" i="0" u="none">
+              <a:rPr sz="1500" b="0" i="0" u="none">
                 <a:solidFill>
                   <a:srgbClr val="243044"/>
                 </a:solidFill>
@@ -30059,7 +30059,7 @@
               <a:buChar char="•"/>
             </a:pPr>
             <a:r>
-              <a:rPr sz="1250" b="0" i="0" u="none">
+              <a:rPr sz="1500" b="0" i="0" u="none">
                 <a:solidFill>
                   <a:srgbClr val="243044"/>
                 </a:solidFill>
@@ -30080,7 +30080,7 @@
               <a:buChar char="•"/>
             </a:pPr>
             <a:r>
-              <a:rPr sz="1250" b="0" i="0" u="none">
+              <a:rPr sz="1500" b="0" i="0" u="none">
                 <a:solidFill>
                   <a:srgbClr val="243044"/>
                 </a:solidFill>
@@ -30161,7 +30161,7 @@
           <a:p>
             <a:pPr algn="l"/>
             <a:r>
-              <a:rPr sz="1400" b="1" i="0" u="none">
+              <a:rPr sz="1650" b="1" i="0" u="none">
                 <a:solidFill>
                   <a:srgbClr val="111111"/>
                 </a:solidFill>
@@ -30229,7 +30229,7 @@
               <a:buChar char="•"/>
             </a:pPr>
             <a:r>
-              <a:rPr sz="1250" b="0" i="0" u="none">
+              <a:rPr sz="1500" b="0" i="0" u="none">
                 <a:solidFill>
                   <a:srgbClr val="243044"/>
                 </a:solidFill>
@@ -30250,7 +30250,7 @@
               <a:buChar char="•"/>
             </a:pPr>
             <a:r>
-              <a:rPr sz="1250" b="0" i="0" u="none">
+              <a:rPr sz="1500" b="0" i="0" u="none">
                 <a:solidFill>
                   <a:srgbClr val="243044"/>
                 </a:solidFill>
@@ -30271,7 +30271,7 @@
               <a:buChar char="•"/>
             </a:pPr>
             <a:r>
-              <a:rPr sz="1250" b="0" i="0" u="none">
+              <a:rPr sz="1500" b="0" i="0" u="none">
                 <a:solidFill>
                   <a:srgbClr val="243044"/>
                 </a:solidFill>
@@ -30292,7 +30292,7 @@
               <a:buChar char="•"/>
             </a:pPr>
             <a:r>
-              <a:rPr sz="1250" b="0" i="0" u="none">
+              <a:rPr sz="1500" b="0" i="0" u="none">
                 <a:solidFill>
                   <a:srgbClr val="243044"/>
                 </a:solidFill>
@@ -30313,7 +30313,7 @@
               <a:buChar char="•"/>
             </a:pPr>
             <a:r>
-              <a:rPr sz="1250" b="0" i="0" u="none">
+              <a:rPr sz="1500" b="0" i="0" u="none">
                 <a:solidFill>
                   <a:srgbClr val="243044"/>
                 </a:solidFill>
@@ -30394,7 +30394,7 @@
           <a:p>
             <a:pPr algn="l"/>
             <a:r>
-              <a:rPr sz="1400" b="1" i="0" u="none">
+              <a:rPr sz="1650" b="1" i="0" u="none">
                 <a:solidFill>
                   <a:srgbClr val="111111"/>
                 </a:solidFill>
@@ -30462,7 +30462,7 @@
               <a:buChar char="•"/>
             </a:pPr>
             <a:r>
-              <a:rPr sz="1250" b="0" i="0" u="none">
+              <a:rPr sz="1500" b="0" i="0" u="none">
                 <a:solidFill>
                   <a:srgbClr val="243044"/>
                 </a:solidFill>
@@ -30483,7 +30483,7 @@
               <a:buChar char="•"/>
             </a:pPr>
             <a:r>
-              <a:rPr sz="1250" b="0" i="0" u="none">
+              <a:rPr sz="1500" b="0" i="0" u="none">
                 <a:solidFill>
                   <a:srgbClr val="243044"/>
                 </a:solidFill>
@@ -30504,7 +30504,7 @@
               <a:buChar char="•"/>
             </a:pPr>
             <a:r>
-              <a:rPr sz="1250" b="0" i="0" u="none">
+              <a:rPr sz="1500" b="0" i="0" u="none">
                 <a:solidFill>
                   <a:srgbClr val="243044"/>
                 </a:solidFill>
@@ -30525,7 +30525,7 @@
               <a:buChar char="•"/>
             </a:pPr>
             <a:r>
-              <a:rPr sz="1250" b="0" i="0" u="none">
+              <a:rPr sz="1500" b="0" i="0" u="none">
                 <a:solidFill>
                   <a:srgbClr val="243044"/>
                 </a:solidFill>
@@ -30606,7 +30606,7 @@
           <a:p>
             <a:pPr algn="l"/>
             <a:r>
-              <a:rPr sz="1400" b="1" i="0" u="none">
+              <a:rPr sz="1650" b="1" i="0" u="none">
                 <a:solidFill>
                   <a:srgbClr val="111111"/>
                 </a:solidFill>
@@ -30674,7 +30674,7 @@
               <a:buChar char="•"/>
             </a:pPr>
             <a:r>
-              <a:rPr sz="1250" b="0" i="0" u="none">
+              <a:rPr sz="1500" b="0" i="0" u="none">
                 <a:solidFill>
                   <a:srgbClr val="243044"/>
                 </a:solidFill>
@@ -30695,7 +30695,7 @@
               <a:buChar char="•"/>
             </a:pPr>
             <a:r>
-              <a:rPr sz="1250" b="0" i="0" u="none">
+              <a:rPr sz="1500" b="0" i="0" u="none">
                 <a:solidFill>
                   <a:srgbClr val="243044"/>
                 </a:solidFill>
@@ -30716,7 +30716,7 @@
               <a:buChar char="•"/>
             </a:pPr>
             <a:r>
-              <a:rPr sz="1250" b="0" i="0" u="none">
+              <a:rPr sz="1500" b="0" i="0" u="none">
                 <a:solidFill>
                   <a:srgbClr val="243044"/>
                 </a:solidFill>
@@ -30737,7 +30737,7 @@
               <a:buChar char="•"/>
             </a:pPr>
             <a:r>
-              <a:rPr sz="1250" b="0" i="0" u="none">
+              <a:rPr sz="1500" b="0" i="0" u="none">
                 <a:solidFill>
                   <a:srgbClr val="243044"/>
                 </a:solidFill>
@@ -30758,7 +30758,7 @@
               <a:buChar char="•"/>
             </a:pPr>
             <a:r>
-              <a:rPr sz="1250" b="0" i="0" u="none">
+              <a:rPr sz="1500" b="0" i="0" u="none">
                 <a:solidFill>
                   <a:srgbClr val="243044"/>
                 </a:solidFill>
@@ -30839,7 +30839,7 @@
           <a:p>
             <a:pPr algn="l"/>
             <a:r>
-              <a:rPr sz="1400" b="1" i="0" u="none">
+              <a:rPr sz="1650" b="1" i="0" u="none">
                 <a:solidFill>
                   <a:srgbClr val="111111"/>
                 </a:solidFill>
@@ -30907,7 +30907,7 @@
               <a:buChar char="•"/>
             </a:pPr>
             <a:r>
-              <a:rPr sz="1250" b="0" i="0" u="none">
+              <a:rPr sz="1500" b="0" i="0" u="none">
                 <a:solidFill>
                   <a:srgbClr val="243044"/>
                 </a:solidFill>
@@ -30928,7 +30928,7 @@
               <a:buChar char="•"/>
             </a:pPr>
             <a:r>
-              <a:rPr sz="1250" b="0" i="0" u="none">
+              <a:rPr sz="1500" b="0" i="0" u="none">
                 <a:solidFill>
                   <a:srgbClr val="243044"/>
                 </a:solidFill>
@@ -30949,7 +30949,7 @@
               <a:buChar char="•"/>
             </a:pPr>
             <a:r>
-              <a:rPr sz="1250" b="0" i="0" u="none">
+              <a:rPr sz="1500" b="0" i="0" u="none">
                 <a:solidFill>
                   <a:srgbClr val="243044"/>
                 </a:solidFill>
@@ -31030,7 +31030,7 @@
           <a:p>
             <a:pPr algn="l"/>
             <a:r>
-              <a:rPr sz="1400" b="1" i="0" u="none">
+              <a:rPr sz="1650" b="1" i="0" u="none">
                 <a:solidFill>
                   <a:srgbClr val="111111"/>
                 </a:solidFill>
@@ -31098,7 +31098,7 @@
               <a:buChar char="•"/>
             </a:pPr>
             <a:r>
-              <a:rPr sz="1250" b="0" i="0" u="none">
+              <a:rPr sz="1500" b="0" i="0" u="none">
                 <a:solidFill>
                   <a:srgbClr val="243044"/>
                 </a:solidFill>
@@ -31119,7 +31119,7 @@
               <a:buChar char="•"/>
             </a:pPr>
             <a:r>
-              <a:rPr sz="1250" b="0" i="0" u="none">
+              <a:rPr sz="1500" b="0" i="0" u="none">
                 <a:solidFill>
                   <a:srgbClr val="243044"/>
                 </a:solidFill>
@@ -31140,7 +31140,7 @@
               <a:buChar char="•"/>
             </a:pPr>
             <a:r>
-              <a:rPr sz="1250" b="0" i="0" u="none">
+              <a:rPr sz="1500" b="0" i="0" u="none">
                 <a:solidFill>
                   <a:srgbClr val="243044"/>
                 </a:solidFill>
@@ -31161,7 +31161,7 @@
               <a:buChar char="•"/>
             </a:pPr>
             <a:r>
-              <a:rPr sz="1250" b="0" i="0" u="none">
+              <a:rPr sz="1500" b="0" i="0" u="none">
                 <a:solidFill>
                   <a:srgbClr val="243044"/>
                 </a:solidFill>
@@ -31242,7 +31242,7 @@
           <a:p>
             <a:pPr algn="l"/>
             <a:r>
-              <a:rPr sz="1400" b="1" i="0" u="none">
+              <a:rPr sz="1650" b="1" i="0" u="none">
                 <a:solidFill>
                   <a:srgbClr val="111111"/>
                 </a:solidFill>
@@ -31310,7 +31310,7 @@
               <a:buChar char="•"/>
             </a:pPr>
             <a:r>
-              <a:rPr sz="1250" b="0" i="0" u="none">
+              <a:rPr sz="1500" b="0" i="0" u="none">
                 <a:solidFill>
                   <a:srgbClr val="243044"/>
                 </a:solidFill>
@@ -31331,7 +31331,7 @@
               <a:buChar char="•"/>
             </a:pPr>
             <a:r>
-              <a:rPr sz="1250" b="0" i="0" u="none">
+              <a:rPr sz="1500" b="0" i="0" u="none">
                 <a:solidFill>
                   <a:srgbClr val="243044"/>
                 </a:solidFill>
@@ -31352,7 +31352,7 @@
               <a:buChar char="•"/>
             </a:pPr>
             <a:r>
-              <a:rPr sz="1250" b="0" i="0" u="none">
+              <a:rPr sz="1500" b="0" i="0" u="none">
                 <a:solidFill>
                   <a:srgbClr val="243044"/>
                 </a:solidFill>
@@ -31373,7 +31373,7 @@
               <a:buChar char="•"/>
             </a:pPr>
             <a:r>
-              <a:rPr sz="1250" b="0" i="0" u="none">
+              <a:rPr sz="1500" b="0" i="0" u="none">
                 <a:solidFill>
                   <a:srgbClr val="243044"/>
                 </a:solidFill>
@@ -31394,7 +31394,7 @@
               <a:buChar char="•"/>
             </a:pPr>
             <a:r>
-              <a:rPr sz="1250" b="0" i="0" u="none">
+              <a:rPr sz="1500" b="0" i="0" u="none">
                 <a:solidFill>
                   <a:srgbClr val="243044"/>
                 </a:solidFill>
@@ -31475,7 +31475,7 @@
           <a:p>
             <a:pPr algn="l"/>
             <a:r>
-              <a:rPr sz="1400" b="1" i="0" u="none">
+              <a:rPr sz="1650" b="1" i="0" u="none">
                 <a:solidFill>
                   <a:srgbClr val="111111"/>
                 </a:solidFill>
@@ -31543,7 +31543,7 @@
               <a:buChar char="•"/>
             </a:pPr>
             <a:r>
-              <a:rPr sz="1250" b="0" i="0" u="none">
+              <a:rPr sz="1500" b="0" i="0" u="none">
                 <a:solidFill>
                   <a:srgbClr val="243044"/>
                 </a:solidFill>
@@ -31564,7 +31564,7 @@
               <a:buChar char="•"/>
             </a:pPr>
             <a:r>
-              <a:rPr sz="1250" b="0" i="0" u="none">
+              <a:rPr sz="1500" b="0" i="0" u="none">
                 <a:solidFill>
                   <a:srgbClr val="243044"/>
                 </a:solidFill>
@@ -31608,7 +31608,7 @@
               <a:buChar char="•"/>
             </a:pPr>
             <a:r>
-              <a:rPr sz="1250" b="0" i="0" u="none">
+              <a:rPr sz="1500" b="0" i="0" u="none">
                 <a:solidFill>
                   <a:srgbClr val="243044"/>
                 </a:solidFill>
@@ -31629,7 +31629,7 @@
               <a:buChar char="•"/>
             </a:pPr>
             <a:r>
-              <a:rPr sz="1250" b="0" i="0" u="none">
+              <a:rPr sz="1500" b="0" i="0" u="none">
                 <a:solidFill>
                   <a:srgbClr val="243044"/>
                 </a:solidFill>
@@ -31710,7 +31710,7 @@
           <a:p>
             <a:pPr algn="l"/>
             <a:r>
-              <a:rPr sz="1400" b="1" i="0" u="none">
+              <a:rPr sz="1650" b="1" i="0" u="none">
                 <a:solidFill>
                   <a:srgbClr val="111111"/>
                 </a:solidFill>
@@ -31778,7 +31778,7 @@
               <a:buChar char="•"/>
             </a:pPr>
             <a:r>
-              <a:rPr sz="1250" b="0" i="0" u="none">
+              <a:rPr sz="1500" b="0" i="0" u="none">
                 <a:solidFill>
                   <a:srgbClr val="243044"/>
                 </a:solidFill>
@@ -31799,7 +31799,7 @@
               <a:buChar char="•"/>
             </a:pPr>
             <a:r>
-              <a:rPr sz="1250" b="0" i="0" u="none">
+              <a:rPr sz="1500" b="0" i="0" u="none">
                 <a:solidFill>
                   <a:srgbClr val="243044"/>
                 </a:solidFill>
@@ -31843,7 +31843,7 @@
               <a:buChar char="•"/>
             </a:pPr>
             <a:r>
-              <a:rPr sz="1250" b="0" i="0" u="none">
+              <a:rPr sz="1500" b="0" i="0" u="none">
                 <a:solidFill>
                   <a:srgbClr val="243044"/>
                 </a:solidFill>
@@ -31864,7 +31864,7 @@
               <a:buChar char="•"/>
             </a:pPr>
             <a:r>
-              <a:rPr sz="1250" b="0" i="0" u="none">
+              <a:rPr sz="1500" b="0" i="0" u="none">
                 <a:solidFill>
                   <a:srgbClr val="243044"/>
                 </a:solidFill>
@@ -32543,7 +32543,7 @@
           <a:p>
             <a:pPr algn="l"/>
             <a:r>
-              <a:rPr sz="1700" b="1" i="0" u="none">
+              <a:rPr sz="2000" b="1" i="0" u="none">
                 <a:solidFill>
                   <a:srgbClr val="1B2A41"/>
                 </a:solidFill>
@@ -32578,7 +32578,7 @@
           <a:p>
             <a:pPr algn="l"/>
             <a:r>
-              <a:rPr sz="1050" b="0" i="1" u="none">
+              <a:rPr sz="1250" b="0" i="1" u="none">
                 <a:solidFill>
                   <a:srgbClr val="1F497D"/>
                 </a:solidFill>
@@ -32729,7 +32729,7 @@
           <a:p>
             <a:pPr algn="l"/>
             <a:r>
-              <a:rPr sz="2000" b="1" i="0" u="none">
+              <a:rPr sz="2350" b="1" i="0" u="none">
                 <a:solidFill>
                   <a:srgbClr val="2A6FB0"/>
                 </a:solidFill>
@@ -32764,7 +32764,7 @@
           <a:p>
             <a:pPr algn="l"/>
             <a:r>
-              <a:rPr sz="1200" b="1" i="0" u="none">
+              <a:rPr sz="1400" b="1" i="0" u="none">
                 <a:solidFill>
                   <a:srgbClr val="5B6778"/>
                 </a:solidFill>
@@ -32803,7 +32803,7 @@
               </a:lnSpc>
             </a:pPr>
             <a:r>
-              <a:rPr sz="1600" b="0" i="0" u="none">
+              <a:rPr sz="1900" b="0" i="0" u="none">
                 <a:solidFill>
                   <a:srgbClr val="243044"/>
                 </a:solidFill>
@@ -32954,7 +32954,7 @@
           <a:p>
             <a:pPr algn="l"/>
             <a:r>
-              <a:rPr sz="2000" b="1" i="0" u="none">
+              <a:rPr sz="2350" b="1" i="0" u="none">
                 <a:solidFill>
                   <a:srgbClr val="0F9E8E"/>
                 </a:solidFill>
@@ -32989,7 +32989,7 @@
           <a:p>
             <a:pPr algn="l"/>
             <a:r>
-              <a:rPr sz="1200" b="1" i="0" u="none">
+              <a:rPr sz="1400" b="1" i="0" u="none">
                 <a:solidFill>
                   <a:srgbClr val="5B6778"/>
                 </a:solidFill>
@@ -33028,7 +33028,7 @@
               </a:lnSpc>
             </a:pPr>
             <a:r>
-              <a:rPr sz="1600" b="0" i="0" u="none">
+              <a:rPr sz="1900" b="0" i="0" u="none">
                 <a:solidFill>
                   <a:srgbClr val="243044"/>
                 </a:solidFill>
@@ -33179,7 +33179,7 @@
           <a:p>
             <a:pPr algn="l"/>
             <a:r>
-              <a:rPr sz="2000" b="1" i="0" u="none">
+              <a:rPr sz="2350" b="1" i="0" u="none">
                 <a:solidFill>
                   <a:srgbClr val="E8731A"/>
                 </a:solidFill>
@@ -33214,7 +33214,7 @@
           <a:p>
             <a:pPr algn="l"/>
             <a:r>
-              <a:rPr sz="1200" b="1" i="0" u="none">
+              <a:rPr sz="1400" b="1" i="0" u="none">
                 <a:solidFill>
                   <a:srgbClr val="5B6778"/>
                 </a:solidFill>
@@ -33253,7 +33253,7 @@
               </a:lnSpc>
             </a:pPr>
             <a:r>
-              <a:rPr sz="1600" b="0" i="0" u="none">
+              <a:rPr sz="1900" b="0" i="0" u="none">
                 <a:solidFill>
                   <a:srgbClr val="243044"/>
                 </a:solidFill>
@@ -33404,7 +33404,7 @@
           <a:p>
             <a:pPr algn="l"/>
             <a:r>
-              <a:rPr sz="2000" b="1" i="0" u="none">
+              <a:rPr sz="2350" b="1" i="0" u="none">
                 <a:solidFill>
                   <a:srgbClr val="16A34A"/>
                 </a:solidFill>
@@ -33439,7 +33439,7 @@
           <a:p>
             <a:pPr algn="l"/>
             <a:r>
-              <a:rPr sz="1200" b="1" i="0" u="none">
+              <a:rPr sz="1400" b="1" i="0" u="none">
                 <a:solidFill>
                   <a:srgbClr val="5B6778"/>
                 </a:solidFill>
@@ -33478,7 +33478,7 @@
               </a:lnSpc>
             </a:pPr>
             <a:r>
-              <a:rPr sz="1600" b="0" i="0" u="none">
+              <a:rPr sz="1900" b="0" i="0" u="none">
                 <a:solidFill>
                   <a:srgbClr val="243044"/>
                 </a:solidFill>
@@ -33629,7 +33629,7 @@
           <a:p>
             <a:pPr algn="l"/>
             <a:r>
-              <a:rPr sz="2000" b="1" i="0" u="none">
+              <a:rPr sz="2350" b="1" i="0" u="none">
                 <a:solidFill>
                   <a:srgbClr val="245C93"/>
                 </a:solidFill>
@@ -33664,7 +33664,7 @@
           <a:p>
             <a:pPr algn="l"/>
             <a:r>
-              <a:rPr sz="1200" b="1" i="0" u="none">
+              <a:rPr sz="1400" b="1" i="0" u="none">
                 <a:solidFill>
                   <a:srgbClr val="5B6778"/>
                 </a:solidFill>
@@ -33703,7 +33703,7 @@
               </a:lnSpc>
             </a:pPr>
             <a:r>
-              <a:rPr sz="1600" b="0" i="0" u="none">
+              <a:rPr sz="1900" b="0" i="0" u="none">
                 <a:solidFill>
                   <a:srgbClr val="243044"/>
                 </a:solidFill>
@@ -33854,7 +33854,7 @@
           <a:p>
             <a:pPr algn="l"/>
             <a:r>
-              <a:rPr sz="2000" b="1" i="0" u="none">
+              <a:rPr sz="2350" b="1" i="0" u="none">
                 <a:solidFill>
                   <a:srgbClr val="DC2626"/>
                 </a:solidFill>
@@ -33889,7 +33889,7 @@
           <a:p>
             <a:pPr algn="l"/>
             <a:r>
-              <a:rPr sz="1200" b="1" i="0" u="none">
+              <a:rPr sz="1400" b="1" i="0" u="none">
                 <a:solidFill>
                   <a:srgbClr val="5B6778"/>
                 </a:solidFill>
@@ -33928,7 +33928,7 @@
               </a:lnSpc>
             </a:pPr>
             <a:r>
-              <a:rPr sz="1600" b="0" i="0" u="none">
+              <a:rPr sz="1900" b="0" i="0" u="none">
                 <a:solidFill>
                   <a:srgbClr val="243044"/>
                 </a:solidFill>

</xml_diff>